<commit_message>
CAMBIOS PARA ESTACION DE EVENTOS DE KIT
</commit_message>
<xml_diff>
--- a/Seguimiento Material Programado/Docs/[PRD]_Seguimiento_Material_Programado.pptx
+++ b/Seguimiento Material Programado/Docs/[PRD]_Seguimiento_Material_Programado.pptx
@@ -5,12 +5,15 @@
     <p:sldMasterId id="2147483648" r:id="rId1"/>
   </p:sldMasterIdLst>
   <p:notesMasterIdLst>
-    <p:notesMasterId r:id="rId5"/>
+    <p:notesMasterId r:id="rId8"/>
   </p:notesMasterIdLst>
   <p:sldIdLst>
     <p:sldId id="344" r:id="rId2"/>
-    <p:sldId id="409" r:id="rId3"/>
-    <p:sldId id="410" r:id="rId4"/>
+    <p:sldId id="412" r:id="rId3"/>
+    <p:sldId id="413" r:id="rId4"/>
+    <p:sldId id="411" r:id="rId5"/>
+    <p:sldId id="409" r:id="rId6"/>
+    <p:sldId id="410" r:id="rId7"/>
   </p:sldIdLst>
   <p:sldSz cx="9144000" cy="6858000" type="screen4x3"/>
   <p:notesSz cx="6858000" cy="9144000"/>
@@ -210,7 +213,7 @@
           <a:p>
             <a:fld id="{A17B1792-3256-4E77-8442-3E205CD69EF5}" type="datetimeFigureOut">
               <a:rPr lang="en-US" smtClean="0"/>
-              <a:t>6/7/2021</a:t>
+              <a:t>6/12/2021</a:t>
             </a:fld>
             <a:endParaRPr lang="en-US"/>
           </a:p>
@@ -656,7 +659,7 @@
           <a:p>
             <a:fld id="{07558649-2619-44F9-8F30-2D6466E57529}" type="datetimeFigureOut">
               <a:rPr lang="en-US" smtClean="0"/>
-              <a:t>6/7/2021</a:t>
+              <a:t>6/12/2021</a:t>
             </a:fld>
             <a:endParaRPr lang="en-US"/>
           </a:p>
@@ -824,7 +827,7 @@
           <a:p>
             <a:fld id="{07558649-2619-44F9-8F30-2D6466E57529}" type="datetimeFigureOut">
               <a:rPr lang="en-US" smtClean="0"/>
-              <a:t>6/7/2021</a:t>
+              <a:t>6/12/2021</a:t>
             </a:fld>
             <a:endParaRPr lang="en-US"/>
           </a:p>
@@ -1002,7 +1005,7 @@
           <a:p>
             <a:fld id="{07558649-2619-44F9-8F30-2D6466E57529}" type="datetimeFigureOut">
               <a:rPr lang="en-US" smtClean="0"/>
-              <a:t>6/7/2021</a:t>
+              <a:t>6/12/2021</a:t>
             </a:fld>
             <a:endParaRPr lang="en-US"/>
           </a:p>
@@ -1170,7 +1173,7 @@
           <a:p>
             <a:fld id="{07558649-2619-44F9-8F30-2D6466E57529}" type="datetimeFigureOut">
               <a:rPr lang="en-US" smtClean="0"/>
-              <a:t>6/7/2021</a:t>
+              <a:t>6/12/2021</a:t>
             </a:fld>
             <a:endParaRPr lang="en-US"/>
           </a:p>
@@ -1415,7 +1418,7 @@
           <a:p>
             <a:fld id="{07558649-2619-44F9-8F30-2D6466E57529}" type="datetimeFigureOut">
               <a:rPr lang="en-US" smtClean="0"/>
-              <a:t>6/7/2021</a:t>
+              <a:t>6/12/2021</a:t>
             </a:fld>
             <a:endParaRPr lang="en-US"/>
           </a:p>
@@ -1700,7 +1703,7 @@
           <a:p>
             <a:fld id="{07558649-2619-44F9-8F30-2D6466E57529}" type="datetimeFigureOut">
               <a:rPr lang="en-US" smtClean="0"/>
-              <a:t>6/7/2021</a:t>
+              <a:t>6/12/2021</a:t>
             </a:fld>
             <a:endParaRPr lang="en-US"/>
           </a:p>
@@ -2119,7 +2122,7 @@
           <a:p>
             <a:fld id="{07558649-2619-44F9-8F30-2D6466E57529}" type="datetimeFigureOut">
               <a:rPr lang="en-US" smtClean="0"/>
-              <a:t>6/7/2021</a:t>
+              <a:t>6/12/2021</a:t>
             </a:fld>
             <a:endParaRPr lang="en-US"/>
           </a:p>
@@ -2236,7 +2239,7 @@
           <a:p>
             <a:fld id="{07558649-2619-44F9-8F30-2D6466E57529}" type="datetimeFigureOut">
               <a:rPr lang="en-US" smtClean="0"/>
-              <a:t>6/7/2021</a:t>
+              <a:t>6/12/2021</a:t>
             </a:fld>
             <a:endParaRPr lang="en-US"/>
           </a:p>
@@ -2331,7 +2334,7 @@
           <a:p>
             <a:fld id="{07558649-2619-44F9-8F30-2D6466E57529}" type="datetimeFigureOut">
               <a:rPr lang="en-US" smtClean="0"/>
-              <a:t>6/7/2021</a:t>
+              <a:t>6/12/2021</a:t>
             </a:fld>
             <a:endParaRPr lang="en-US"/>
           </a:p>
@@ -2606,7 +2609,7 @@
           <a:p>
             <a:fld id="{07558649-2619-44F9-8F30-2D6466E57529}" type="datetimeFigureOut">
               <a:rPr lang="en-US" smtClean="0"/>
-              <a:t>6/7/2021</a:t>
+              <a:t>6/12/2021</a:t>
             </a:fld>
             <a:endParaRPr lang="en-US"/>
           </a:p>
@@ -2858,7 +2861,7 @@
           <a:p>
             <a:fld id="{07558649-2619-44F9-8F30-2D6466E57529}" type="datetimeFigureOut">
               <a:rPr lang="en-US" smtClean="0"/>
-              <a:t>6/7/2021</a:t>
+              <a:t>6/12/2021</a:t>
             </a:fld>
             <a:endParaRPr lang="en-US"/>
           </a:p>
@@ -3078,7 +3081,7 @@
           <a:p>
             <a:fld id="{07558649-2619-44F9-8F30-2D6466E57529}" type="datetimeFigureOut">
               <a:rPr lang="en-US" smtClean="0"/>
-              <a:t>6/7/2021</a:t>
+              <a:t>6/12/2021</a:t>
             </a:fld>
             <a:endParaRPr lang="en-US"/>
           </a:p>
@@ -3495,7 +3498,7 @@
               <a:rPr lang="es-MX" b="1" dirty="0">
                 <a:latin typeface="Century Gothic" panose="020B0502020202020204" pitchFamily="34" charset="0"/>
               </a:rPr>
-              <a:t>31/05/2021 – 04/06/2021</a:t>
+              <a:t>07/06/2021 – 11/06/2021</a:t>
             </a:r>
             <a:endParaRPr lang="es-MX" dirty="0">
               <a:latin typeface="Century Gothic" panose="020B0502020202020204" pitchFamily="34" charset="0"/>
@@ -3517,6 +3520,938 @@
 </file>
 
 <file path=ppt/slides/slide2.xml><?xml version="1.0" encoding="utf-8"?>
+<p:sld xmlns:a="http://schemas.openxmlformats.org/drawingml/2006/main" xmlns:r="http://schemas.openxmlformats.org/officeDocument/2006/relationships" xmlns:p="http://schemas.openxmlformats.org/presentationml/2006/main">
+  <p:cSld>
+    <p:spTree>
+      <p:nvGrpSpPr>
+        <p:cNvPr id="1" name=""/>
+        <p:cNvGrpSpPr/>
+        <p:nvPr/>
+      </p:nvGrpSpPr>
+      <p:grpSpPr>
+        <a:xfrm>
+          <a:off x="0" y="0"/>
+          <a:ext cx="0" cy="0"/>
+          <a:chOff x="0" y="0"/>
+          <a:chExt cx="0" cy="0"/>
+        </a:xfrm>
+      </p:grpSpPr>
+      <p:sp>
+        <p:nvSpPr>
+          <p:cNvPr id="8" name="Title 1"/>
+          <p:cNvSpPr txBox="1">
+            <a:spLocks/>
+          </p:cNvSpPr>
+          <p:nvPr/>
+        </p:nvSpPr>
+        <p:spPr>
+          <a:xfrm>
+            <a:off x="1087408" y="274638"/>
+            <a:ext cx="7229008" cy="634082"/>
+          </a:xfrm>
+          <a:prstGeom prst="rect">
+            <a:avLst/>
+          </a:prstGeom>
+        </p:spPr>
+        <p:txBody>
+          <a:bodyPr/>
+          <a:lstStyle>
+            <a:lvl1pPr algn="ctr" defTabSz="914400" rtl="0" eaLnBrk="1" latinLnBrk="0" hangingPunct="1">
+              <a:spcBef>
+                <a:spcPct val="0"/>
+              </a:spcBef>
+              <a:buNone/>
+              <a:defRPr sz="4400" kern="1200">
+                <a:solidFill>
+                  <a:schemeClr val="tx1"/>
+                </a:solidFill>
+                <a:latin typeface="+mj-lt"/>
+                <a:ea typeface="+mj-ea"/>
+                <a:cs typeface="+mj-cs"/>
+              </a:defRPr>
+            </a:lvl1pPr>
+          </a:lstStyle>
+          <a:p>
+            <a:pPr algn="l"/>
+            <a:r>
+              <a:rPr lang="es-ES" sz="2000" dirty="0">
+                <a:solidFill>
+                  <a:srgbClr val="3F1900"/>
+                </a:solidFill>
+              </a:rPr>
+              <a:t>Seguimiento de Material Programado.</a:t>
+            </a:r>
+            <a:endParaRPr lang="en-US" sz="2000" dirty="0">
+              <a:solidFill>
+                <a:srgbClr val="3F1900"/>
+              </a:solidFill>
+            </a:endParaRPr>
+          </a:p>
+        </p:txBody>
+      </p:sp>
+      <p:sp>
+        <p:nvSpPr>
+          <p:cNvPr id="4" name="Content Placeholder 3"/>
+          <p:cNvSpPr txBox="1">
+            <a:spLocks/>
+          </p:cNvSpPr>
+          <p:nvPr/>
+        </p:nvSpPr>
+        <p:spPr>
+          <a:xfrm>
+            <a:off x="1331640" y="1196753"/>
+            <a:ext cx="7488832" cy="5137780"/>
+          </a:xfrm>
+          <a:prstGeom prst="rect">
+            <a:avLst/>
+          </a:prstGeom>
+        </p:spPr>
+        <p:txBody>
+          <a:bodyPr>
+            <a:normAutofit/>
+          </a:bodyPr>
+          <a:lstStyle>
+            <a:lvl1pPr marL="342900" indent="-342900" algn="l" defTabSz="914400" rtl="0" eaLnBrk="1" latinLnBrk="0" hangingPunct="1">
+              <a:spcBef>
+                <a:spcPct val="20000"/>
+              </a:spcBef>
+              <a:buFont typeface="Arial" panose="020B0604020202020204" pitchFamily="34" charset="0"/>
+              <a:buChar char="•"/>
+              <a:defRPr sz="3200" kern="1200">
+                <a:solidFill>
+                  <a:schemeClr val="tx1"/>
+                </a:solidFill>
+                <a:latin typeface="+mn-lt"/>
+                <a:ea typeface="+mn-ea"/>
+                <a:cs typeface="+mn-cs"/>
+              </a:defRPr>
+            </a:lvl1pPr>
+            <a:lvl2pPr marL="742950" indent="-285750" algn="l" defTabSz="914400" rtl="0" eaLnBrk="1" latinLnBrk="0" hangingPunct="1">
+              <a:spcBef>
+                <a:spcPct val="20000"/>
+              </a:spcBef>
+              <a:buFont typeface="Arial" panose="020B0604020202020204" pitchFamily="34" charset="0"/>
+              <a:buChar char="–"/>
+              <a:defRPr sz="2800" kern="1200">
+                <a:solidFill>
+                  <a:schemeClr val="tx1"/>
+                </a:solidFill>
+                <a:latin typeface="+mn-lt"/>
+                <a:ea typeface="+mn-ea"/>
+                <a:cs typeface="+mn-cs"/>
+              </a:defRPr>
+            </a:lvl2pPr>
+            <a:lvl3pPr marL="1143000" indent="-228600" algn="l" defTabSz="914400" rtl="0" eaLnBrk="1" latinLnBrk="0" hangingPunct="1">
+              <a:spcBef>
+                <a:spcPct val="20000"/>
+              </a:spcBef>
+              <a:buFont typeface="Arial" panose="020B0604020202020204" pitchFamily="34" charset="0"/>
+              <a:buChar char="•"/>
+              <a:defRPr sz="2400" kern="1200">
+                <a:solidFill>
+                  <a:schemeClr val="tx1"/>
+                </a:solidFill>
+                <a:latin typeface="+mn-lt"/>
+                <a:ea typeface="+mn-ea"/>
+                <a:cs typeface="+mn-cs"/>
+              </a:defRPr>
+            </a:lvl3pPr>
+            <a:lvl4pPr marL="1600200" indent="-228600" algn="l" defTabSz="914400" rtl="0" eaLnBrk="1" latinLnBrk="0" hangingPunct="1">
+              <a:spcBef>
+                <a:spcPct val="20000"/>
+              </a:spcBef>
+              <a:buFont typeface="Arial" panose="020B0604020202020204" pitchFamily="34" charset="0"/>
+              <a:buChar char="–"/>
+              <a:defRPr sz="2000" kern="1200">
+                <a:solidFill>
+                  <a:schemeClr val="tx1"/>
+                </a:solidFill>
+                <a:latin typeface="+mn-lt"/>
+                <a:ea typeface="+mn-ea"/>
+                <a:cs typeface="+mn-cs"/>
+              </a:defRPr>
+            </a:lvl4pPr>
+            <a:lvl5pPr marL="2057400" indent="-228600" algn="l" defTabSz="914400" rtl="0" eaLnBrk="1" latinLnBrk="0" hangingPunct="1">
+              <a:spcBef>
+                <a:spcPct val="20000"/>
+              </a:spcBef>
+              <a:buFont typeface="Arial" panose="020B0604020202020204" pitchFamily="34" charset="0"/>
+              <a:buChar char="»"/>
+              <a:defRPr sz="2000" kern="1200">
+                <a:solidFill>
+                  <a:schemeClr val="tx1"/>
+                </a:solidFill>
+                <a:latin typeface="+mn-lt"/>
+                <a:ea typeface="+mn-ea"/>
+                <a:cs typeface="+mn-cs"/>
+              </a:defRPr>
+            </a:lvl5pPr>
+            <a:lvl6pPr marL="2514600" indent="-228600" algn="l" defTabSz="914400" rtl="0" eaLnBrk="1" latinLnBrk="0" hangingPunct="1">
+              <a:spcBef>
+                <a:spcPct val="20000"/>
+              </a:spcBef>
+              <a:buFont typeface="Arial" panose="020B0604020202020204" pitchFamily="34" charset="0"/>
+              <a:buChar char="•"/>
+              <a:defRPr sz="2000" kern="1200">
+                <a:solidFill>
+                  <a:schemeClr val="tx1"/>
+                </a:solidFill>
+                <a:latin typeface="+mn-lt"/>
+                <a:ea typeface="+mn-ea"/>
+                <a:cs typeface="+mn-cs"/>
+              </a:defRPr>
+            </a:lvl6pPr>
+            <a:lvl7pPr marL="2971800" indent="-228600" algn="l" defTabSz="914400" rtl="0" eaLnBrk="1" latinLnBrk="0" hangingPunct="1">
+              <a:spcBef>
+                <a:spcPct val="20000"/>
+              </a:spcBef>
+              <a:buFont typeface="Arial" panose="020B0604020202020204" pitchFamily="34" charset="0"/>
+              <a:buChar char="•"/>
+              <a:defRPr sz="2000" kern="1200">
+                <a:solidFill>
+                  <a:schemeClr val="tx1"/>
+                </a:solidFill>
+                <a:latin typeface="+mn-lt"/>
+                <a:ea typeface="+mn-ea"/>
+                <a:cs typeface="+mn-cs"/>
+              </a:defRPr>
+            </a:lvl7pPr>
+            <a:lvl8pPr marL="3429000" indent="-228600" algn="l" defTabSz="914400" rtl="0" eaLnBrk="1" latinLnBrk="0" hangingPunct="1">
+              <a:spcBef>
+                <a:spcPct val="20000"/>
+              </a:spcBef>
+              <a:buFont typeface="Arial" panose="020B0604020202020204" pitchFamily="34" charset="0"/>
+              <a:buChar char="•"/>
+              <a:defRPr sz="2000" kern="1200">
+                <a:solidFill>
+                  <a:schemeClr val="tx1"/>
+                </a:solidFill>
+                <a:latin typeface="+mn-lt"/>
+                <a:ea typeface="+mn-ea"/>
+                <a:cs typeface="+mn-cs"/>
+              </a:defRPr>
+            </a:lvl8pPr>
+            <a:lvl9pPr marL="3886200" indent="-228600" algn="l" defTabSz="914400" rtl="0" eaLnBrk="1" latinLnBrk="0" hangingPunct="1">
+              <a:spcBef>
+                <a:spcPct val="20000"/>
+              </a:spcBef>
+              <a:buFont typeface="Arial" panose="020B0604020202020204" pitchFamily="34" charset="0"/>
+              <a:buChar char="•"/>
+              <a:defRPr sz="2000" kern="1200">
+                <a:solidFill>
+                  <a:schemeClr val="tx1"/>
+                </a:solidFill>
+                <a:latin typeface="+mn-lt"/>
+                <a:ea typeface="+mn-ea"/>
+                <a:cs typeface="+mn-cs"/>
+              </a:defRPr>
+            </a:lvl9pPr>
+          </a:lstStyle>
+          <a:p>
+            <a:pPr marL="0" indent="0" algn="just">
+              <a:buFont typeface="Arial" panose="020B0604020202020204" pitchFamily="34" charset="0"/>
+              <a:buNone/>
+            </a:pPr>
+            <a:endParaRPr lang="en-US" sz="2000" i="1"/>
+          </a:p>
+        </p:txBody>
+      </p:sp>
+      <p:sp>
+        <p:nvSpPr>
+          <p:cNvPr id="9" name="Rectangle 9">
+            <a:extLst>
+              <a:ext uri="{FF2B5EF4-FFF2-40B4-BE49-F238E27FC236}">
+                <a16:creationId xmlns:a16="http://schemas.microsoft.com/office/drawing/2014/main" id="{F1A6E0C6-DADC-4B10-8F5F-048CE74BBF1F}"/>
+              </a:ext>
+            </a:extLst>
+          </p:cNvPr>
+          <p:cNvSpPr/>
+          <p:nvPr/>
+        </p:nvSpPr>
+        <p:spPr>
+          <a:xfrm>
+            <a:off x="1331640" y="1095133"/>
+            <a:ext cx="7632848" cy="646331"/>
+          </a:xfrm>
+          <a:prstGeom prst="rect">
+            <a:avLst/>
+          </a:prstGeom>
+        </p:spPr>
+        <p:txBody>
+          <a:bodyPr wrap="square">
+            <a:spAutoFit/>
+          </a:bodyPr>
+          <a:lstStyle/>
+          <a:p>
+            <a:pPr>
+              <a:buFont typeface="Arial" panose="020B0604020202020204" pitchFamily="34" charset="0"/>
+              <a:buChar char="•"/>
+            </a:pPr>
+            <a:r>
+              <a:rPr lang="es-ES" sz="1200" b="0" i="0" dirty="0">
+                <a:solidFill>
+                  <a:srgbClr val="222222"/>
+                </a:solidFill>
+                <a:effectLst/>
+                <a:latin typeface="Segoe UI" panose="020B0502040204020203" pitchFamily="34" charset="0"/>
+              </a:rPr>
+              <a:t> Se </a:t>
+            </a:r>
+            <a:r>
+              <a:rPr lang="es-ES" sz="1200" dirty="0">
+                <a:solidFill>
+                  <a:srgbClr val="222222"/>
+                </a:solidFill>
+                <a:latin typeface="Segoe UI" panose="020B0502040204020203" pitchFamily="34" charset="0"/>
+              </a:rPr>
+              <a:t>agrego a Pantalla </a:t>
+            </a:r>
+            <a:r>
+              <a:rPr lang="es-ES" sz="1200" b="1" dirty="0">
+                <a:solidFill>
+                  <a:srgbClr val="222222"/>
+                </a:solidFill>
+                <a:latin typeface="Segoe UI" panose="020B0502040204020203" pitchFamily="34" charset="0"/>
+              </a:rPr>
+              <a:t>Work in Progress </a:t>
+            </a:r>
+            <a:r>
+              <a:rPr lang="es-ES" sz="1200" dirty="0">
+                <a:solidFill>
+                  <a:srgbClr val="222222"/>
+                </a:solidFill>
+                <a:latin typeface="Segoe UI" panose="020B0502040204020203" pitchFamily="34" charset="0"/>
+              </a:rPr>
+              <a:t>la columna </a:t>
+            </a:r>
+            <a:r>
+              <a:rPr lang="es-ES" sz="1200" b="1" dirty="0">
+                <a:solidFill>
+                  <a:srgbClr val="222222"/>
+                </a:solidFill>
+                <a:latin typeface="Segoe UI" panose="020B0502040204020203" pitchFamily="34" charset="0"/>
+              </a:rPr>
+              <a:t># Parte Etiqueta </a:t>
+            </a:r>
+            <a:r>
+              <a:rPr lang="es-ES" sz="1200" dirty="0">
+                <a:solidFill>
+                  <a:srgbClr val="222222"/>
+                </a:solidFill>
+                <a:latin typeface="Segoe UI" panose="020B0502040204020203" pitchFamily="34" charset="0"/>
+              </a:rPr>
+              <a:t>esta columna servirá como validación para saber si el numero de parte en la etiqueta es diferente al numero de parte programado en la orden y se le puso colores de fondo alas columnas para identificar los estatus actual y siguiente del Kit.</a:t>
+            </a:r>
+            <a:endParaRPr lang="es-ES" sz="1200" b="0" i="0" dirty="0">
+              <a:solidFill>
+                <a:srgbClr val="222222"/>
+              </a:solidFill>
+              <a:effectLst/>
+              <a:latin typeface="Segoe UI" panose="020B0502040204020203" pitchFamily="34" charset="0"/>
+            </a:endParaRPr>
+          </a:p>
+        </p:txBody>
+      </p:sp>
+      <p:pic>
+        <p:nvPicPr>
+          <p:cNvPr id="6" name="Imagen 5" descr="Tabla&#10;&#10;Descripción generada automáticamente">
+            <a:extLst>
+              <a:ext uri="{FF2B5EF4-FFF2-40B4-BE49-F238E27FC236}">
+                <a16:creationId xmlns:a16="http://schemas.microsoft.com/office/drawing/2014/main" id="{BD82A97D-ABB9-4205-9F7C-536F7CE09D4F}"/>
+              </a:ext>
+            </a:extLst>
+          </p:cNvPr>
+          <p:cNvPicPr>
+            <a:picLocks noChangeAspect="1"/>
+          </p:cNvPicPr>
+          <p:nvPr/>
+        </p:nvPicPr>
+        <p:blipFill>
+          <a:blip r:embed="rId2">
+            <a:extLst>
+              <a:ext uri="{28A0092B-C50C-407E-A947-70E740481C1C}">
+                <a14:useLocalDpi xmlns:a14="http://schemas.microsoft.com/office/drawing/2010/main" val="0"/>
+              </a:ext>
+            </a:extLst>
+          </a:blip>
+          <a:stretch>
+            <a:fillRect/>
+          </a:stretch>
+        </p:blipFill>
+        <p:spPr>
+          <a:xfrm>
+            <a:off x="1087408" y="1720220"/>
+            <a:ext cx="8041352" cy="5137780"/>
+          </a:xfrm>
+          <a:prstGeom prst="rect">
+            <a:avLst/>
+          </a:prstGeom>
+        </p:spPr>
+      </p:pic>
+      <p:sp>
+        <p:nvSpPr>
+          <p:cNvPr id="7" name="Rectángulo 6">
+            <a:extLst>
+              <a:ext uri="{FF2B5EF4-FFF2-40B4-BE49-F238E27FC236}">
+                <a16:creationId xmlns:a16="http://schemas.microsoft.com/office/drawing/2014/main" id="{59971469-E25D-44F1-B4EF-62F0A5931806}"/>
+              </a:ext>
+            </a:extLst>
+          </p:cNvPr>
+          <p:cNvSpPr/>
+          <p:nvPr/>
+        </p:nvSpPr>
+        <p:spPr>
+          <a:xfrm>
+            <a:off x="3203848" y="2552964"/>
+            <a:ext cx="1080120" cy="4305036"/>
+          </a:xfrm>
+          <a:prstGeom prst="rect">
+            <a:avLst/>
+          </a:prstGeom>
+          <a:noFill/>
+          <a:ln>
+            <a:solidFill>
+              <a:srgbClr val="FF0000"/>
+            </a:solidFill>
+          </a:ln>
+        </p:spPr>
+        <p:style>
+          <a:lnRef idx="2">
+            <a:schemeClr val="accent1">
+              <a:shade val="50000"/>
+            </a:schemeClr>
+          </a:lnRef>
+          <a:fillRef idx="1">
+            <a:schemeClr val="accent1"/>
+          </a:fillRef>
+          <a:effectRef idx="0">
+            <a:schemeClr val="accent1"/>
+          </a:effectRef>
+          <a:fontRef idx="minor">
+            <a:schemeClr val="lt1"/>
+          </a:fontRef>
+        </p:style>
+        <p:txBody>
+          <a:bodyPr rtlCol="0" anchor="ctr"/>
+          <a:lstStyle/>
+          <a:p>
+            <a:pPr algn="ctr"/>
+            <a:endParaRPr lang="en-US"/>
+          </a:p>
+        </p:txBody>
+      </p:sp>
+      <p:sp>
+        <p:nvSpPr>
+          <p:cNvPr id="10" name="Rectángulo 9">
+            <a:extLst>
+              <a:ext uri="{FF2B5EF4-FFF2-40B4-BE49-F238E27FC236}">
+                <a16:creationId xmlns:a16="http://schemas.microsoft.com/office/drawing/2014/main" id="{A6FD8D13-7BF9-4AE9-8147-7BF00C3E51A9}"/>
+              </a:ext>
+            </a:extLst>
+          </p:cNvPr>
+          <p:cNvSpPr/>
+          <p:nvPr/>
+        </p:nvSpPr>
+        <p:spPr>
+          <a:xfrm>
+            <a:off x="6804248" y="2552964"/>
+            <a:ext cx="1152128" cy="4305036"/>
+          </a:xfrm>
+          <a:prstGeom prst="rect">
+            <a:avLst/>
+          </a:prstGeom>
+          <a:noFill/>
+          <a:ln>
+            <a:solidFill>
+              <a:srgbClr val="FF0000"/>
+            </a:solidFill>
+          </a:ln>
+        </p:spPr>
+        <p:style>
+          <a:lnRef idx="2">
+            <a:schemeClr val="accent1">
+              <a:shade val="50000"/>
+            </a:schemeClr>
+          </a:lnRef>
+          <a:fillRef idx="1">
+            <a:schemeClr val="accent1"/>
+          </a:fillRef>
+          <a:effectRef idx="0">
+            <a:schemeClr val="accent1"/>
+          </a:effectRef>
+          <a:fontRef idx="minor">
+            <a:schemeClr val="lt1"/>
+          </a:fontRef>
+        </p:style>
+        <p:txBody>
+          <a:bodyPr rtlCol="0" anchor="ctr"/>
+          <a:lstStyle/>
+          <a:p>
+            <a:pPr algn="ctr"/>
+            <a:endParaRPr lang="en-US"/>
+          </a:p>
+        </p:txBody>
+      </p:sp>
+    </p:spTree>
+    <p:extLst>
+      <p:ext uri="{BB962C8B-B14F-4D97-AF65-F5344CB8AC3E}">
+        <p14:creationId xmlns:p14="http://schemas.microsoft.com/office/powerpoint/2010/main" val="3206816744"/>
+      </p:ext>
+    </p:extLst>
+  </p:cSld>
+  <p:clrMapOvr>
+    <a:masterClrMapping/>
+  </p:clrMapOvr>
+</p:sld>
+</file>
+
+<file path=ppt/slides/slide3.xml><?xml version="1.0" encoding="utf-8"?>
+<p:sld xmlns:a="http://schemas.openxmlformats.org/drawingml/2006/main" xmlns:r="http://schemas.openxmlformats.org/officeDocument/2006/relationships" xmlns:p="http://schemas.openxmlformats.org/presentationml/2006/main">
+  <p:cSld>
+    <p:spTree>
+      <p:nvGrpSpPr>
+        <p:cNvPr id="1" name=""/>
+        <p:cNvGrpSpPr/>
+        <p:nvPr/>
+      </p:nvGrpSpPr>
+      <p:grpSpPr>
+        <a:xfrm>
+          <a:off x="0" y="0"/>
+          <a:ext cx="0" cy="0"/>
+          <a:chOff x="0" y="0"/>
+          <a:chExt cx="0" cy="0"/>
+        </a:xfrm>
+      </p:grpSpPr>
+      <p:sp>
+        <p:nvSpPr>
+          <p:cNvPr id="8" name="Title 1"/>
+          <p:cNvSpPr txBox="1">
+            <a:spLocks/>
+          </p:cNvSpPr>
+          <p:nvPr/>
+        </p:nvSpPr>
+        <p:spPr>
+          <a:xfrm>
+            <a:off x="1087408" y="274638"/>
+            <a:ext cx="7229008" cy="634082"/>
+          </a:xfrm>
+          <a:prstGeom prst="rect">
+            <a:avLst/>
+          </a:prstGeom>
+        </p:spPr>
+        <p:txBody>
+          <a:bodyPr/>
+          <a:lstStyle>
+            <a:lvl1pPr algn="ctr" defTabSz="914400" rtl="0" eaLnBrk="1" latinLnBrk="0" hangingPunct="1">
+              <a:spcBef>
+                <a:spcPct val="0"/>
+              </a:spcBef>
+              <a:buNone/>
+              <a:defRPr sz="4400" kern="1200">
+                <a:solidFill>
+                  <a:schemeClr val="tx1"/>
+                </a:solidFill>
+                <a:latin typeface="+mj-lt"/>
+                <a:ea typeface="+mj-ea"/>
+                <a:cs typeface="+mj-cs"/>
+              </a:defRPr>
+            </a:lvl1pPr>
+          </a:lstStyle>
+          <a:p>
+            <a:pPr algn="l"/>
+            <a:r>
+              <a:rPr lang="es-ES" sz="2000" dirty="0">
+                <a:solidFill>
+                  <a:srgbClr val="3F1900"/>
+                </a:solidFill>
+              </a:rPr>
+              <a:t>Seguimiento de Material Programado.</a:t>
+            </a:r>
+            <a:endParaRPr lang="en-US" sz="2000" dirty="0">
+              <a:solidFill>
+                <a:srgbClr val="3F1900"/>
+              </a:solidFill>
+            </a:endParaRPr>
+          </a:p>
+        </p:txBody>
+      </p:sp>
+      <p:sp>
+        <p:nvSpPr>
+          <p:cNvPr id="4" name="Content Placeholder 3"/>
+          <p:cNvSpPr txBox="1">
+            <a:spLocks/>
+          </p:cNvSpPr>
+          <p:nvPr/>
+        </p:nvSpPr>
+        <p:spPr>
+          <a:xfrm>
+            <a:off x="1331640" y="1196753"/>
+            <a:ext cx="7488832" cy="5137780"/>
+          </a:xfrm>
+          <a:prstGeom prst="rect">
+            <a:avLst/>
+          </a:prstGeom>
+        </p:spPr>
+        <p:txBody>
+          <a:bodyPr>
+            <a:normAutofit/>
+          </a:bodyPr>
+          <a:lstStyle>
+            <a:lvl1pPr marL="342900" indent="-342900" algn="l" defTabSz="914400" rtl="0" eaLnBrk="1" latinLnBrk="0" hangingPunct="1">
+              <a:spcBef>
+                <a:spcPct val="20000"/>
+              </a:spcBef>
+              <a:buFont typeface="Arial" panose="020B0604020202020204" pitchFamily="34" charset="0"/>
+              <a:buChar char="•"/>
+              <a:defRPr sz="3200" kern="1200">
+                <a:solidFill>
+                  <a:schemeClr val="tx1"/>
+                </a:solidFill>
+                <a:latin typeface="+mn-lt"/>
+                <a:ea typeface="+mn-ea"/>
+                <a:cs typeface="+mn-cs"/>
+              </a:defRPr>
+            </a:lvl1pPr>
+            <a:lvl2pPr marL="742950" indent="-285750" algn="l" defTabSz="914400" rtl="0" eaLnBrk="1" latinLnBrk="0" hangingPunct="1">
+              <a:spcBef>
+                <a:spcPct val="20000"/>
+              </a:spcBef>
+              <a:buFont typeface="Arial" panose="020B0604020202020204" pitchFamily="34" charset="0"/>
+              <a:buChar char="–"/>
+              <a:defRPr sz="2800" kern="1200">
+                <a:solidFill>
+                  <a:schemeClr val="tx1"/>
+                </a:solidFill>
+                <a:latin typeface="+mn-lt"/>
+                <a:ea typeface="+mn-ea"/>
+                <a:cs typeface="+mn-cs"/>
+              </a:defRPr>
+            </a:lvl2pPr>
+            <a:lvl3pPr marL="1143000" indent="-228600" algn="l" defTabSz="914400" rtl="0" eaLnBrk="1" latinLnBrk="0" hangingPunct="1">
+              <a:spcBef>
+                <a:spcPct val="20000"/>
+              </a:spcBef>
+              <a:buFont typeface="Arial" panose="020B0604020202020204" pitchFamily="34" charset="0"/>
+              <a:buChar char="•"/>
+              <a:defRPr sz="2400" kern="1200">
+                <a:solidFill>
+                  <a:schemeClr val="tx1"/>
+                </a:solidFill>
+                <a:latin typeface="+mn-lt"/>
+                <a:ea typeface="+mn-ea"/>
+                <a:cs typeface="+mn-cs"/>
+              </a:defRPr>
+            </a:lvl3pPr>
+            <a:lvl4pPr marL="1600200" indent="-228600" algn="l" defTabSz="914400" rtl="0" eaLnBrk="1" latinLnBrk="0" hangingPunct="1">
+              <a:spcBef>
+                <a:spcPct val="20000"/>
+              </a:spcBef>
+              <a:buFont typeface="Arial" panose="020B0604020202020204" pitchFamily="34" charset="0"/>
+              <a:buChar char="–"/>
+              <a:defRPr sz="2000" kern="1200">
+                <a:solidFill>
+                  <a:schemeClr val="tx1"/>
+                </a:solidFill>
+                <a:latin typeface="+mn-lt"/>
+                <a:ea typeface="+mn-ea"/>
+                <a:cs typeface="+mn-cs"/>
+              </a:defRPr>
+            </a:lvl4pPr>
+            <a:lvl5pPr marL="2057400" indent="-228600" algn="l" defTabSz="914400" rtl="0" eaLnBrk="1" latinLnBrk="0" hangingPunct="1">
+              <a:spcBef>
+                <a:spcPct val="20000"/>
+              </a:spcBef>
+              <a:buFont typeface="Arial" panose="020B0604020202020204" pitchFamily="34" charset="0"/>
+              <a:buChar char="»"/>
+              <a:defRPr sz="2000" kern="1200">
+                <a:solidFill>
+                  <a:schemeClr val="tx1"/>
+                </a:solidFill>
+                <a:latin typeface="+mn-lt"/>
+                <a:ea typeface="+mn-ea"/>
+                <a:cs typeface="+mn-cs"/>
+              </a:defRPr>
+            </a:lvl5pPr>
+            <a:lvl6pPr marL="2514600" indent="-228600" algn="l" defTabSz="914400" rtl="0" eaLnBrk="1" latinLnBrk="0" hangingPunct="1">
+              <a:spcBef>
+                <a:spcPct val="20000"/>
+              </a:spcBef>
+              <a:buFont typeface="Arial" panose="020B0604020202020204" pitchFamily="34" charset="0"/>
+              <a:buChar char="•"/>
+              <a:defRPr sz="2000" kern="1200">
+                <a:solidFill>
+                  <a:schemeClr val="tx1"/>
+                </a:solidFill>
+                <a:latin typeface="+mn-lt"/>
+                <a:ea typeface="+mn-ea"/>
+                <a:cs typeface="+mn-cs"/>
+              </a:defRPr>
+            </a:lvl6pPr>
+            <a:lvl7pPr marL="2971800" indent="-228600" algn="l" defTabSz="914400" rtl="0" eaLnBrk="1" latinLnBrk="0" hangingPunct="1">
+              <a:spcBef>
+                <a:spcPct val="20000"/>
+              </a:spcBef>
+              <a:buFont typeface="Arial" panose="020B0604020202020204" pitchFamily="34" charset="0"/>
+              <a:buChar char="•"/>
+              <a:defRPr sz="2000" kern="1200">
+                <a:solidFill>
+                  <a:schemeClr val="tx1"/>
+                </a:solidFill>
+                <a:latin typeface="+mn-lt"/>
+                <a:ea typeface="+mn-ea"/>
+                <a:cs typeface="+mn-cs"/>
+              </a:defRPr>
+            </a:lvl7pPr>
+            <a:lvl8pPr marL="3429000" indent="-228600" algn="l" defTabSz="914400" rtl="0" eaLnBrk="1" latinLnBrk="0" hangingPunct="1">
+              <a:spcBef>
+                <a:spcPct val="20000"/>
+              </a:spcBef>
+              <a:buFont typeface="Arial" panose="020B0604020202020204" pitchFamily="34" charset="0"/>
+              <a:buChar char="•"/>
+              <a:defRPr sz="2000" kern="1200">
+                <a:solidFill>
+                  <a:schemeClr val="tx1"/>
+                </a:solidFill>
+                <a:latin typeface="+mn-lt"/>
+                <a:ea typeface="+mn-ea"/>
+                <a:cs typeface="+mn-cs"/>
+              </a:defRPr>
+            </a:lvl8pPr>
+            <a:lvl9pPr marL="3886200" indent="-228600" algn="l" defTabSz="914400" rtl="0" eaLnBrk="1" latinLnBrk="0" hangingPunct="1">
+              <a:spcBef>
+                <a:spcPct val="20000"/>
+              </a:spcBef>
+              <a:buFont typeface="Arial" panose="020B0604020202020204" pitchFamily="34" charset="0"/>
+              <a:buChar char="•"/>
+              <a:defRPr sz="2000" kern="1200">
+                <a:solidFill>
+                  <a:schemeClr val="tx1"/>
+                </a:solidFill>
+                <a:latin typeface="+mn-lt"/>
+                <a:ea typeface="+mn-ea"/>
+                <a:cs typeface="+mn-cs"/>
+              </a:defRPr>
+            </a:lvl9pPr>
+          </a:lstStyle>
+          <a:p>
+            <a:pPr marL="0" indent="0" algn="just">
+              <a:buFont typeface="Arial" panose="020B0604020202020204" pitchFamily="34" charset="0"/>
+              <a:buNone/>
+            </a:pPr>
+            <a:endParaRPr lang="en-US" sz="2000" i="1"/>
+          </a:p>
+        </p:txBody>
+      </p:sp>
+      <p:sp>
+        <p:nvSpPr>
+          <p:cNvPr id="9" name="Rectangle 9">
+            <a:extLst>
+              <a:ext uri="{FF2B5EF4-FFF2-40B4-BE49-F238E27FC236}">
+                <a16:creationId xmlns:a16="http://schemas.microsoft.com/office/drawing/2014/main" id="{F1A6E0C6-DADC-4B10-8F5F-048CE74BBF1F}"/>
+              </a:ext>
+            </a:extLst>
+          </p:cNvPr>
+          <p:cNvSpPr/>
+          <p:nvPr/>
+        </p:nvSpPr>
+        <p:spPr>
+          <a:xfrm>
+            <a:off x="1331640" y="1095133"/>
+            <a:ext cx="7632848" cy="646331"/>
+          </a:xfrm>
+          <a:prstGeom prst="rect">
+            <a:avLst/>
+          </a:prstGeom>
+        </p:spPr>
+        <p:txBody>
+          <a:bodyPr wrap="square">
+            <a:spAutoFit/>
+          </a:bodyPr>
+          <a:lstStyle/>
+          <a:p>
+            <a:pPr>
+              <a:buFont typeface="Arial" panose="020B0604020202020204" pitchFamily="34" charset="0"/>
+              <a:buChar char="•"/>
+            </a:pPr>
+            <a:r>
+              <a:rPr lang="es-ES" sz="1200" b="0" i="0" dirty="0">
+                <a:solidFill>
+                  <a:srgbClr val="222222"/>
+                </a:solidFill>
+                <a:effectLst/>
+                <a:latin typeface="Segoe UI" panose="020B0502040204020203" pitchFamily="34" charset="0"/>
+              </a:rPr>
+              <a:t> Se creo pantalla </a:t>
+            </a:r>
+            <a:r>
+              <a:rPr lang="es-ES" sz="1200" b="1" i="0" dirty="0">
+                <a:solidFill>
+                  <a:srgbClr val="222222"/>
+                </a:solidFill>
+                <a:effectLst/>
+                <a:latin typeface="Segoe UI" panose="020B0502040204020203" pitchFamily="34" charset="0"/>
+              </a:rPr>
+              <a:t>Estación de Evento </a:t>
+            </a:r>
+            <a:r>
+              <a:rPr lang="es-ES" sz="1200" i="0" dirty="0">
+                <a:solidFill>
+                  <a:srgbClr val="222222"/>
+                </a:solidFill>
+                <a:effectLst/>
+                <a:latin typeface="Segoe UI" panose="020B0502040204020203" pitchFamily="34" charset="0"/>
+              </a:rPr>
+              <a:t>que servirá para escanear y guardar la información de los diferentes procesos que se le realizaran a un Kit, esta pantalla listara todo el material que se escanee durante el día en la estación</a:t>
+            </a:r>
+            <a:r>
+              <a:rPr lang="es-ES" sz="1200" dirty="0">
+                <a:solidFill>
+                  <a:srgbClr val="222222"/>
+                </a:solidFill>
+                <a:latin typeface="Segoe UI" panose="020B0502040204020203" pitchFamily="34" charset="0"/>
+              </a:rPr>
+              <a:t>.</a:t>
+            </a:r>
+            <a:endParaRPr lang="es-ES" sz="1200" b="0" i="0" dirty="0">
+              <a:solidFill>
+                <a:srgbClr val="222222"/>
+              </a:solidFill>
+              <a:effectLst/>
+              <a:latin typeface="Segoe UI" panose="020B0502040204020203" pitchFamily="34" charset="0"/>
+            </a:endParaRPr>
+          </a:p>
+        </p:txBody>
+      </p:sp>
+      <p:pic>
+        <p:nvPicPr>
+          <p:cNvPr id="7" name="Imagen 6" descr="Interfaz de usuario gráfica, Texto, Aplicación&#10;&#10;Descripción generada automáticamente">
+            <a:extLst>
+              <a:ext uri="{FF2B5EF4-FFF2-40B4-BE49-F238E27FC236}">
+                <a16:creationId xmlns:a16="http://schemas.microsoft.com/office/drawing/2014/main" id="{E59A03BA-39B9-493A-881F-B0C20255A0C9}"/>
+              </a:ext>
+            </a:extLst>
+          </p:cNvPr>
+          <p:cNvPicPr>
+            <a:picLocks noChangeAspect="1"/>
+          </p:cNvPicPr>
+          <p:nvPr/>
+        </p:nvPicPr>
+        <p:blipFill>
+          <a:blip r:embed="rId2">
+            <a:extLst>
+              <a:ext uri="{28A0092B-C50C-407E-A947-70E740481C1C}">
+                <a14:useLocalDpi xmlns:a14="http://schemas.microsoft.com/office/drawing/2010/main" val="0"/>
+              </a:ext>
+            </a:extLst>
+          </a:blip>
+          <a:stretch>
+            <a:fillRect/>
+          </a:stretch>
+        </p:blipFill>
+        <p:spPr>
+          <a:xfrm>
+            <a:off x="1087408" y="1741464"/>
+            <a:ext cx="7949088" cy="4927896"/>
+          </a:xfrm>
+          <a:prstGeom prst="rect">
+            <a:avLst/>
+          </a:prstGeom>
+        </p:spPr>
+      </p:pic>
+    </p:spTree>
+    <p:extLst>
+      <p:ext uri="{BB962C8B-B14F-4D97-AF65-F5344CB8AC3E}">
+        <p14:creationId xmlns:p14="http://schemas.microsoft.com/office/powerpoint/2010/main" val="1881130846"/>
+      </p:ext>
+    </p:extLst>
+  </p:cSld>
+  <p:clrMapOvr>
+    <a:masterClrMapping/>
+  </p:clrMapOvr>
+</p:sld>
+</file>
+
+<file path=ppt/slides/slide4.xml><?xml version="1.0" encoding="utf-8"?>
+<p:sld xmlns:a="http://schemas.openxmlformats.org/drawingml/2006/main" xmlns:r="http://schemas.openxmlformats.org/officeDocument/2006/relationships" xmlns:p="http://schemas.openxmlformats.org/presentationml/2006/main">
+  <p:cSld>
+    <p:spTree>
+      <p:nvGrpSpPr>
+        <p:cNvPr id="1" name=""/>
+        <p:cNvGrpSpPr/>
+        <p:nvPr/>
+      </p:nvGrpSpPr>
+      <p:grpSpPr>
+        <a:xfrm>
+          <a:off x="0" y="0"/>
+          <a:ext cx="0" cy="0"/>
+          <a:chOff x="0" y="0"/>
+          <a:chExt cx="0" cy="0"/>
+        </a:xfrm>
+      </p:grpSpPr>
+      <p:sp>
+        <p:nvSpPr>
+          <p:cNvPr id="5" name="Title 1"/>
+          <p:cNvSpPr txBox="1">
+            <a:spLocks/>
+          </p:cNvSpPr>
+          <p:nvPr/>
+        </p:nvSpPr>
+        <p:spPr>
+          <a:xfrm>
+            <a:off x="1187624" y="2564904"/>
+            <a:ext cx="7772400" cy="1470025"/>
+          </a:xfrm>
+          <a:prstGeom prst="rect">
+            <a:avLst/>
+          </a:prstGeom>
+        </p:spPr>
+        <p:txBody>
+          <a:bodyPr vert="horz" lIns="91440" tIns="45720" rIns="91440" bIns="45720" rtlCol="0" anchor="ctr">
+            <a:normAutofit/>
+          </a:bodyPr>
+          <a:lstStyle>
+            <a:lvl1pPr algn="ctr" defTabSz="914400" rtl="0" eaLnBrk="1" latinLnBrk="0" hangingPunct="1">
+              <a:spcBef>
+                <a:spcPct val="0"/>
+              </a:spcBef>
+              <a:buNone/>
+              <a:defRPr sz="4400" kern="1200">
+                <a:solidFill>
+                  <a:schemeClr val="tx1"/>
+                </a:solidFill>
+                <a:latin typeface="+mj-lt"/>
+                <a:ea typeface="+mj-ea"/>
+                <a:cs typeface="+mj-cs"/>
+              </a:defRPr>
+            </a:lvl1pPr>
+          </a:lstStyle>
+          <a:p>
+            <a:r>
+              <a:rPr lang="es-MX" b="1" dirty="0">
+                <a:latin typeface="Century Gothic" panose="020B0502020202020204" pitchFamily="34" charset="0"/>
+              </a:rPr>
+              <a:t>31/05/2021 – 04/06/2021</a:t>
+            </a:r>
+            <a:endParaRPr lang="es-MX" dirty="0">
+              <a:latin typeface="Century Gothic" panose="020B0502020202020204" pitchFamily="34" charset="0"/>
+            </a:endParaRPr>
+          </a:p>
+        </p:txBody>
+      </p:sp>
+    </p:spTree>
+    <p:extLst>
+      <p:ext uri="{BB962C8B-B14F-4D97-AF65-F5344CB8AC3E}">
+        <p14:creationId xmlns:p14="http://schemas.microsoft.com/office/powerpoint/2010/main" val="3402791518"/>
+      </p:ext>
+    </p:extLst>
+  </p:cSld>
+  <p:clrMapOvr>
+    <a:masterClrMapping/>
+  </p:clrMapOvr>
+</p:sld>
+</file>
+
+<file path=ppt/slides/slide5.xml><?xml version="1.0" encoding="utf-8"?>
 <p:sld xmlns:a="http://schemas.openxmlformats.org/drawingml/2006/main" xmlns:r="http://schemas.openxmlformats.org/officeDocument/2006/relationships" xmlns:p="http://schemas.openxmlformats.org/presentationml/2006/main">
   <p:cSld>
     <p:spTree>
@@ -3914,7 +4849,7 @@
 </p:sld>
 </file>
 
-<file path=ppt/slides/slide3.xml><?xml version="1.0" encoding="utf-8"?>
+<file path=ppt/slides/slide6.xml><?xml version="1.0" encoding="utf-8"?>
 <p:sld xmlns:a="http://schemas.openxmlformats.org/drawingml/2006/main" xmlns:r="http://schemas.openxmlformats.org/officeDocument/2006/relationships" xmlns:p="http://schemas.openxmlformats.org/presentationml/2006/main">
   <p:cSld>
     <p:spTree>

</xml_diff>

<commit_message>
CAMBIOS POR CREACION DE REPORTE DE MATERIAL ESCANEADO EN LOCACIONES
</commit_message>
<xml_diff>
--- a/Seguimiento Material Programado/Docs/[PRD]_Seguimiento_Material_Programado.pptx
+++ b/Seguimiento Material Programado/Docs/[PRD]_Seguimiento_Material_Programado.pptx
@@ -5,15 +5,17 @@
     <p:sldMasterId id="2147483648" r:id="rId1"/>
   </p:sldMasterIdLst>
   <p:notesMasterIdLst>
-    <p:notesMasterId r:id="rId8"/>
+    <p:notesMasterId r:id="rId10"/>
   </p:notesMasterIdLst>
   <p:sldIdLst>
     <p:sldId id="344" r:id="rId2"/>
-    <p:sldId id="412" r:id="rId3"/>
-    <p:sldId id="413" r:id="rId4"/>
-    <p:sldId id="411" r:id="rId5"/>
-    <p:sldId id="409" r:id="rId6"/>
-    <p:sldId id="410" r:id="rId7"/>
+    <p:sldId id="415" r:id="rId3"/>
+    <p:sldId id="414" r:id="rId4"/>
+    <p:sldId id="412" r:id="rId5"/>
+    <p:sldId id="413" r:id="rId6"/>
+    <p:sldId id="411" r:id="rId7"/>
+    <p:sldId id="409" r:id="rId8"/>
+    <p:sldId id="410" r:id="rId9"/>
   </p:sldIdLst>
   <p:sldSz cx="9144000" cy="6858000" type="screen4x3"/>
   <p:notesSz cx="6858000" cy="9144000"/>
@@ -213,7 +215,7 @@
           <a:p>
             <a:fld id="{A17B1792-3256-4E77-8442-3E205CD69EF5}" type="datetimeFigureOut">
               <a:rPr lang="en-US" smtClean="0"/>
-              <a:t>6/12/2021</a:t>
+              <a:t>7/9/2021</a:t>
             </a:fld>
             <a:endParaRPr lang="en-US"/>
           </a:p>
@@ -659,7 +661,7 @@
           <a:p>
             <a:fld id="{07558649-2619-44F9-8F30-2D6466E57529}" type="datetimeFigureOut">
               <a:rPr lang="en-US" smtClean="0"/>
-              <a:t>6/12/2021</a:t>
+              <a:t>7/9/2021</a:t>
             </a:fld>
             <a:endParaRPr lang="en-US"/>
           </a:p>
@@ -827,7 +829,7 @@
           <a:p>
             <a:fld id="{07558649-2619-44F9-8F30-2D6466E57529}" type="datetimeFigureOut">
               <a:rPr lang="en-US" smtClean="0"/>
-              <a:t>6/12/2021</a:t>
+              <a:t>7/9/2021</a:t>
             </a:fld>
             <a:endParaRPr lang="en-US"/>
           </a:p>
@@ -1005,7 +1007,7 @@
           <a:p>
             <a:fld id="{07558649-2619-44F9-8F30-2D6466E57529}" type="datetimeFigureOut">
               <a:rPr lang="en-US" smtClean="0"/>
-              <a:t>6/12/2021</a:t>
+              <a:t>7/9/2021</a:t>
             </a:fld>
             <a:endParaRPr lang="en-US"/>
           </a:p>
@@ -1173,7 +1175,7 @@
           <a:p>
             <a:fld id="{07558649-2619-44F9-8F30-2D6466E57529}" type="datetimeFigureOut">
               <a:rPr lang="en-US" smtClean="0"/>
-              <a:t>6/12/2021</a:t>
+              <a:t>7/9/2021</a:t>
             </a:fld>
             <a:endParaRPr lang="en-US"/>
           </a:p>
@@ -1418,7 +1420,7 @@
           <a:p>
             <a:fld id="{07558649-2619-44F9-8F30-2D6466E57529}" type="datetimeFigureOut">
               <a:rPr lang="en-US" smtClean="0"/>
-              <a:t>6/12/2021</a:t>
+              <a:t>7/9/2021</a:t>
             </a:fld>
             <a:endParaRPr lang="en-US"/>
           </a:p>
@@ -1703,7 +1705,7 @@
           <a:p>
             <a:fld id="{07558649-2619-44F9-8F30-2D6466E57529}" type="datetimeFigureOut">
               <a:rPr lang="en-US" smtClean="0"/>
-              <a:t>6/12/2021</a:t>
+              <a:t>7/9/2021</a:t>
             </a:fld>
             <a:endParaRPr lang="en-US"/>
           </a:p>
@@ -2122,7 +2124,7 @@
           <a:p>
             <a:fld id="{07558649-2619-44F9-8F30-2D6466E57529}" type="datetimeFigureOut">
               <a:rPr lang="en-US" smtClean="0"/>
-              <a:t>6/12/2021</a:t>
+              <a:t>7/9/2021</a:t>
             </a:fld>
             <a:endParaRPr lang="en-US"/>
           </a:p>
@@ -2239,7 +2241,7 @@
           <a:p>
             <a:fld id="{07558649-2619-44F9-8F30-2D6466E57529}" type="datetimeFigureOut">
               <a:rPr lang="en-US" smtClean="0"/>
-              <a:t>6/12/2021</a:t>
+              <a:t>7/9/2021</a:t>
             </a:fld>
             <a:endParaRPr lang="en-US"/>
           </a:p>
@@ -2334,7 +2336,7 @@
           <a:p>
             <a:fld id="{07558649-2619-44F9-8F30-2D6466E57529}" type="datetimeFigureOut">
               <a:rPr lang="en-US" smtClean="0"/>
-              <a:t>6/12/2021</a:t>
+              <a:t>7/9/2021</a:t>
             </a:fld>
             <a:endParaRPr lang="en-US"/>
           </a:p>
@@ -2609,7 +2611,7 @@
           <a:p>
             <a:fld id="{07558649-2619-44F9-8F30-2D6466E57529}" type="datetimeFigureOut">
               <a:rPr lang="en-US" smtClean="0"/>
-              <a:t>6/12/2021</a:t>
+              <a:t>7/9/2021</a:t>
             </a:fld>
             <a:endParaRPr lang="en-US"/>
           </a:p>
@@ -2861,7 +2863,7 @@
           <a:p>
             <a:fld id="{07558649-2619-44F9-8F30-2D6466E57529}" type="datetimeFigureOut">
               <a:rPr lang="en-US" smtClean="0"/>
-              <a:t>6/12/2021</a:t>
+              <a:t>7/9/2021</a:t>
             </a:fld>
             <a:endParaRPr lang="en-US"/>
           </a:p>
@@ -3081,7 +3083,7 @@
           <a:p>
             <a:fld id="{07558649-2619-44F9-8F30-2D6466E57529}" type="datetimeFigureOut">
               <a:rPr lang="en-US" smtClean="0"/>
-              <a:t>6/12/2021</a:t>
+              <a:t>7/9/2021</a:t>
             </a:fld>
             <a:endParaRPr lang="en-US"/>
           </a:p>
@@ -3498,7 +3500,7 @@
               <a:rPr lang="es-MX" b="1" dirty="0">
                 <a:latin typeface="Century Gothic" panose="020B0502020202020204" pitchFamily="34" charset="0"/>
               </a:rPr>
-              <a:t>07/06/2021 – 11/06/2021</a:t>
+              <a:t>05/07/2021 – 09/07/2021</a:t>
             </a:r>
             <a:endParaRPr lang="es-MX" dirty="0">
               <a:latin typeface="Century Gothic" panose="020B0502020202020204" pitchFamily="34" charset="0"/>
@@ -3520,6 +3522,1023 @@
 </file>
 
 <file path=ppt/slides/slide2.xml><?xml version="1.0" encoding="utf-8"?>
+<p:sld xmlns:a="http://schemas.openxmlformats.org/drawingml/2006/main" xmlns:r="http://schemas.openxmlformats.org/officeDocument/2006/relationships" xmlns:p="http://schemas.openxmlformats.org/presentationml/2006/main">
+  <p:cSld>
+    <p:spTree>
+      <p:nvGrpSpPr>
+        <p:cNvPr id="1" name=""/>
+        <p:cNvGrpSpPr/>
+        <p:nvPr/>
+      </p:nvGrpSpPr>
+      <p:grpSpPr>
+        <a:xfrm>
+          <a:off x="0" y="0"/>
+          <a:ext cx="0" cy="0"/>
+          <a:chOff x="0" y="0"/>
+          <a:chExt cx="0" cy="0"/>
+        </a:xfrm>
+      </p:grpSpPr>
+      <p:sp>
+        <p:nvSpPr>
+          <p:cNvPr id="8" name="Title 1"/>
+          <p:cNvSpPr txBox="1">
+            <a:spLocks/>
+          </p:cNvSpPr>
+          <p:nvPr/>
+        </p:nvSpPr>
+        <p:spPr>
+          <a:xfrm>
+            <a:off x="1087408" y="274638"/>
+            <a:ext cx="7229008" cy="634082"/>
+          </a:xfrm>
+          <a:prstGeom prst="rect">
+            <a:avLst/>
+          </a:prstGeom>
+        </p:spPr>
+        <p:txBody>
+          <a:bodyPr/>
+          <a:lstStyle>
+            <a:lvl1pPr algn="ctr" defTabSz="914400" rtl="0" eaLnBrk="1" latinLnBrk="0" hangingPunct="1">
+              <a:spcBef>
+                <a:spcPct val="0"/>
+              </a:spcBef>
+              <a:buNone/>
+              <a:defRPr sz="4400" kern="1200">
+                <a:solidFill>
+                  <a:schemeClr val="tx1"/>
+                </a:solidFill>
+                <a:latin typeface="+mj-lt"/>
+                <a:ea typeface="+mj-ea"/>
+                <a:cs typeface="+mj-cs"/>
+              </a:defRPr>
+            </a:lvl1pPr>
+          </a:lstStyle>
+          <a:p>
+            <a:pPr algn="l"/>
+            <a:r>
+              <a:rPr lang="es-ES" sz="2000" dirty="0">
+                <a:solidFill>
+                  <a:srgbClr val="3F1900"/>
+                </a:solidFill>
+              </a:rPr>
+              <a:t>Seguimiento de Material Programado.</a:t>
+            </a:r>
+            <a:endParaRPr lang="en-US" sz="2000" dirty="0">
+              <a:solidFill>
+                <a:srgbClr val="3F1900"/>
+              </a:solidFill>
+            </a:endParaRPr>
+          </a:p>
+        </p:txBody>
+      </p:sp>
+      <p:sp>
+        <p:nvSpPr>
+          <p:cNvPr id="4" name="Content Placeholder 3"/>
+          <p:cNvSpPr txBox="1">
+            <a:spLocks/>
+          </p:cNvSpPr>
+          <p:nvPr/>
+        </p:nvSpPr>
+        <p:spPr>
+          <a:xfrm>
+            <a:off x="1331640" y="1196753"/>
+            <a:ext cx="7488832" cy="5137780"/>
+          </a:xfrm>
+          <a:prstGeom prst="rect">
+            <a:avLst/>
+          </a:prstGeom>
+        </p:spPr>
+        <p:txBody>
+          <a:bodyPr>
+            <a:normAutofit/>
+          </a:bodyPr>
+          <a:lstStyle>
+            <a:lvl1pPr marL="342900" indent="-342900" algn="l" defTabSz="914400" rtl="0" eaLnBrk="1" latinLnBrk="0" hangingPunct="1">
+              <a:spcBef>
+                <a:spcPct val="20000"/>
+              </a:spcBef>
+              <a:buFont typeface="Arial" panose="020B0604020202020204" pitchFamily="34" charset="0"/>
+              <a:buChar char="•"/>
+              <a:defRPr sz="3200" kern="1200">
+                <a:solidFill>
+                  <a:schemeClr val="tx1"/>
+                </a:solidFill>
+                <a:latin typeface="+mn-lt"/>
+                <a:ea typeface="+mn-ea"/>
+                <a:cs typeface="+mn-cs"/>
+              </a:defRPr>
+            </a:lvl1pPr>
+            <a:lvl2pPr marL="742950" indent="-285750" algn="l" defTabSz="914400" rtl="0" eaLnBrk="1" latinLnBrk="0" hangingPunct="1">
+              <a:spcBef>
+                <a:spcPct val="20000"/>
+              </a:spcBef>
+              <a:buFont typeface="Arial" panose="020B0604020202020204" pitchFamily="34" charset="0"/>
+              <a:buChar char="–"/>
+              <a:defRPr sz="2800" kern="1200">
+                <a:solidFill>
+                  <a:schemeClr val="tx1"/>
+                </a:solidFill>
+                <a:latin typeface="+mn-lt"/>
+                <a:ea typeface="+mn-ea"/>
+                <a:cs typeface="+mn-cs"/>
+              </a:defRPr>
+            </a:lvl2pPr>
+            <a:lvl3pPr marL="1143000" indent="-228600" algn="l" defTabSz="914400" rtl="0" eaLnBrk="1" latinLnBrk="0" hangingPunct="1">
+              <a:spcBef>
+                <a:spcPct val="20000"/>
+              </a:spcBef>
+              <a:buFont typeface="Arial" panose="020B0604020202020204" pitchFamily="34" charset="0"/>
+              <a:buChar char="•"/>
+              <a:defRPr sz="2400" kern="1200">
+                <a:solidFill>
+                  <a:schemeClr val="tx1"/>
+                </a:solidFill>
+                <a:latin typeface="+mn-lt"/>
+                <a:ea typeface="+mn-ea"/>
+                <a:cs typeface="+mn-cs"/>
+              </a:defRPr>
+            </a:lvl3pPr>
+            <a:lvl4pPr marL="1600200" indent="-228600" algn="l" defTabSz="914400" rtl="0" eaLnBrk="1" latinLnBrk="0" hangingPunct="1">
+              <a:spcBef>
+                <a:spcPct val="20000"/>
+              </a:spcBef>
+              <a:buFont typeface="Arial" panose="020B0604020202020204" pitchFamily="34" charset="0"/>
+              <a:buChar char="–"/>
+              <a:defRPr sz="2000" kern="1200">
+                <a:solidFill>
+                  <a:schemeClr val="tx1"/>
+                </a:solidFill>
+                <a:latin typeface="+mn-lt"/>
+                <a:ea typeface="+mn-ea"/>
+                <a:cs typeface="+mn-cs"/>
+              </a:defRPr>
+            </a:lvl4pPr>
+            <a:lvl5pPr marL="2057400" indent="-228600" algn="l" defTabSz="914400" rtl="0" eaLnBrk="1" latinLnBrk="0" hangingPunct="1">
+              <a:spcBef>
+                <a:spcPct val="20000"/>
+              </a:spcBef>
+              <a:buFont typeface="Arial" panose="020B0604020202020204" pitchFamily="34" charset="0"/>
+              <a:buChar char="»"/>
+              <a:defRPr sz="2000" kern="1200">
+                <a:solidFill>
+                  <a:schemeClr val="tx1"/>
+                </a:solidFill>
+                <a:latin typeface="+mn-lt"/>
+                <a:ea typeface="+mn-ea"/>
+                <a:cs typeface="+mn-cs"/>
+              </a:defRPr>
+            </a:lvl5pPr>
+            <a:lvl6pPr marL="2514600" indent="-228600" algn="l" defTabSz="914400" rtl="0" eaLnBrk="1" latinLnBrk="0" hangingPunct="1">
+              <a:spcBef>
+                <a:spcPct val="20000"/>
+              </a:spcBef>
+              <a:buFont typeface="Arial" panose="020B0604020202020204" pitchFamily="34" charset="0"/>
+              <a:buChar char="•"/>
+              <a:defRPr sz="2000" kern="1200">
+                <a:solidFill>
+                  <a:schemeClr val="tx1"/>
+                </a:solidFill>
+                <a:latin typeface="+mn-lt"/>
+                <a:ea typeface="+mn-ea"/>
+                <a:cs typeface="+mn-cs"/>
+              </a:defRPr>
+            </a:lvl6pPr>
+            <a:lvl7pPr marL="2971800" indent="-228600" algn="l" defTabSz="914400" rtl="0" eaLnBrk="1" latinLnBrk="0" hangingPunct="1">
+              <a:spcBef>
+                <a:spcPct val="20000"/>
+              </a:spcBef>
+              <a:buFont typeface="Arial" panose="020B0604020202020204" pitchFamily="34" charset="0"/>
+              <a:buChar char="•"/>
+              <a:defRPr sz="2000" kern="1200">
+                <a:solidFill>
+                  <a:schemeClr val="tx1"/>
+                </a:solidFill>
+                <a:latin typeface="+mn-lt"/>
+                <a:ea typeface="+mn-ea"/>
+                <a:cs typeface="+mn-cs"/>
+              </a:defRPr>
+            </a:lvl7pPr>
+            <a:lvl8pPr marL="3429000" indent="-228600" algn="l" defTabSz="914400" rtl="0" eaLnBrk="1" latinLnBrk="0" hangingPunct="1">
+              <a:spcBef>
+                <a:spcPct val="20000"/>
+              </a:spcBef>
+              <a:buFont typeface="Arial" panose="020B0604020202020204" pitchFamily="34" charset="0"/>
+              <a:buChar char="•"/>
+              <a:defRPr sz="2000" kern="1200">
+                <a:solidFill>
+                  <a:schemeClr val="tx1"/>
+                </a:solidFill>
+                <a:latin typeface="+mn-lt"/>
+                <a:ea typeface="+mn-ea"/>
+                <a:cs typeface="+mn-cs"/>
+              </a:defRPr>
+            </a:lvl8pPr>
+            <a:lvl9pPr marL="3886200" indent="-228600" algn="l" defTabSz="914400" rtl="0" eaLnBrk="1" latinLnBrk="0" hangingPunct="1">
+              <a:spcBef>
+                <a:spcPct val="20000"/>
+              </a:spcBef>
+              <a:buFont typeface="Arial" panose="020B0604020202020204" pitchFamily="34" charset="0"/>
+              <a:buChar char="•"/>
+              <a:defRPr sz="2000" kern="1200">
+                <a:solidFill>
+                  <a:schemeClr val="tx1"/>
+                </a:solidFill>
+                <a:latin typeface="+mn-lt"/>
+                <a:ea typeface="+mn-ea"/>
+                <a:cs typeface="+mn-cs"/>
+              </a:defRPr>
+            </a:lvl9pPr>
+          </a:lstStyle>
+          <a:p>
+            <a:pPr marL="0" indent="0" algn="just">
+              <a:buFont typeface="Arial" panose="020B0604020202020204" pitchFamily="34" charset="0"/>
+              <a:buNone/>
+            </a:pPr>
+            <a:endParaRPr lang="en-US" sz="2000" i="1"/>
+          </a:p>
+        </p:txBody>
+      </p:sp>
+      <p:sp>
+        <p:nvSpPr>
+          <p:cNvPr id="9" name="Rectangle 9">
+            <a:extLst>
+              <a:ext uri="{FF2B5EF4-FFF2-40B4-BE49-F238E27FC236}">
+                <a16:creationId xmlns:a16="http://schemas.microsoft.com/office/drawing/2014/main" id="{F1A6E0C6-DADC-4B10-8F5F-048CE74BBF1F}"/>
+              </a:ext>
+            </a:extLst>
+          </p:cNvPr>
+          <p:cNvSpPr/>
+          <p:nvPr/>
+        </p:nvSpPr>
+        <p:spPr>
+          <a:xfrm>
+            <a:off x="1115616" y="1082884"/>
+            <a:ext cx="7956376" cy="830997"/>
+          </a:xfrm>
+          <a:prstGeom prst="rect">
+            <a:avLst/>
+          </a:prstGeom>
+        </p:spPr>
+        <p:txBody>
+          <a:bodyPr wrap="square">
+            <a:spAutoFit/>
+          </a:bodyPr>
+          <a:lstStyle/>
+          <a:p>
+            <a:pPr>
+              <a:buFont typeface="Arial" panose="020B0604020202020204" pitchFamily="34" charset="0"/>
+              <a:buChar char="•"/>
+            </a:pPr>
+            <a:r>
+              <a:rPr lang="es-ES" sz="1200" dirty="0">
+                <a:solidFill>
+                  <a:srgbClr val="222222"/>
+                </a:solidFill>
+                <a:latin typeface="Segoe UI" panose="020B0502040204020203" pitchFamily="34" charset="0"/>
+              </a:rPr>
+              <a:t> Se agrego Pantalla </a:t>
+            </a:r>
+            <a:r>
+              <a:rPr lang="es-ES" sz="1200" b="1" dirty="0">
+                <a:solidFill>
+                  <a:srgbClr val="222222"/>
+                </a:solidFill>
+                <a:latin typeface="Segoe UI" panose="020B0502040204020203" pitchFamily="34" charset="0"/>
+              </a:rPr>
+              <a:t>Reporte de material escaneado por proceso </a:t>
+            </a:r>
+            <a:r>
+              <a:rPr lang="es-ES" sz="1200" dirty="0">
+                <a:solidFill>
+                  <a:srgbClr val="222222"/>
+                </a:solidFill>
+                <a:latin typeface="Segoe UI" panose="020B0502040204020203" pitchFamily="34" charset="0"/>
+              </a:rPr>
+              <a:t>en</a:t>
+            </a:r>
+            <a:r>
+              <a:rPr lang="es-ES" sz="1200" b="1" dirty="0">
+                <a:solidFill>
+                  <a:srgbClr val="222222"/>
+                </a:solidFill>
+                <a:latin typeface="Segoe UI" panose="020B0502040204020203" pitchFamily="34" charset="0"/>
+              </a:rPr>
+              <a:t> </a:t>
+            </a:r>
+            <a:r>
+              <a:rPr lang="en-US" sz="1200" dirty="0" err="1">
+                <a:solidFill>
+                  <a:srgbClr val="222222"/>
+                </a:solidFill>
+                <a:latin typeface="Segoe UI" panose="020B0502040204020203" pitchFamily="34" charset="0"/>
+              </a:rPr>
+              <a:t>esta</a:t>
+            </a:r>
+            <a:r>
+              <a:rPr lang="en-US" sz="1200" dirty="0">
+                <a:solidFill>
+                  <a:srgbClr val="222222"/>
+                </a:solidFill>
+                <a:latin typeface="Segoe UI" panose="020B0502040204020203" pitchFamily="34" charset="0"/>
+              </a:rPr>
+              <a:t> </a:t>
+            </a:r>
+            <a:r>
+              <a:rPr lang="en-US" sz="1200" dirty="0" err="1">
+                <a:solidFill>
+                  <a:srgbClr val="222222"/>
+                </a:solidFill>
+                <a:latin typeface="Segoe UI" panose="020B0502040204020203" pitchFamily="34" charset="0"/>
+              </a:rPr>
+              <a:t>pantalla</a:t>
+            </a:r>
+            <a:r>
+              <a:rPr lang="en-US" sz="1200" dirty="0">
+                <a:solidFill>
+                  <a:srgbClr val="222222"/>
+                </a:solidFill>
+                <a:latin typeface="Segoe UI" panose="020B0502040204020203" pitchFamily="34" charset="0"/>
+              </a:rPr>
+              <a:t> </a:t>
+            </a:r>
+            <a:r>
+              <a:rPr lang="en-US" sz="1200" dirty="0" err="1">
+                <a:solidFill>
+                  <a:srgbClr val="222222"/>
+                </a:solidFill>
+                <a:latin typeface="Segoe UI" panose="020B0502040204020203" pitchFamily="34" charset="0"/>
+              </a:rPr>
+              <a:t>podremos</a:t>
+            </a:r>
+            <a:r>
+              <a:rPr lang="en-US" sz="1200" dirty="0">
+                <a:solidFill>
+                  <a:srgbClr val="222222"/>
+                </a:solidFill>
+                <a:latin typeface="Segoe UI" panose="020B0502040204020203" pitchFamily="34" charset="0"/>
+              </a:rPr>
+              <a:t> </a:t>
+            </a:r>
+            <a:r>
+              <a:rPr lang="en-US" sz="1200" dirty="0" err="1">
+                <a:solidFill>
+                  <a:srgbClr val="222222"/>
+                </a:solidFill>
+                <a:latin typeface="Segoe UI" panose="020B0502040204020203" pitchFamily="34" charset="0"/>
+              </a:rPr>
+              <a:t>consultar</a:t>
+            </a:r>
+            <a:r>
+              <a:rPr lang="en-US" sz="1200" dirty="0">
+                <a:solidFill>
+                  <a:srgbClr val="222222"/>
+                </a:solidFill>
+                <a:latin typeface="Segoe UI" panose="020B0502040204020203" pitchFamily="34" charset="0"/>
+              </a:rPr>
+              <a:t> la </a:t>
+            </a:r>
+            <a:r>
+              <a:rPr lang="en-US" sz="1200" dirty="0" err="1">
+                <a:solidFill>
+                  <a:srgbClr val="222222"/>
+                </a:solidFill>
+                <a:latin typeface="Segoe UI" panose="020B0502040204020203" pitchFamily="34" charset="0"/>
+              </a:rPr>
+              <a:t>información</a:t>
+            </a:r>
+            <a:r>
+              <a:rPr lang="en-US" sz="1200" dirty="0">
+                <a:solidFill>
+                  <a:srgbClr val="222222"/>
+                </a:solidFill>
+                <a:latin typeface="Segoe UI" panose="020B0502040204020203" pitchFamily="34" charset="0"/>
+              </a:rPr>
+              <a:t> </a:t>
+            </a:r>
+            <a:r>
+              <a:rPr lang="en-US" sz="1200" dirty="0" err="1">
+                <a:solidFill>
+                  <a:srgbClr val="222222"/>
+                </a:solidFill>
+                <a:latin typeface="Segoe UI" panose="020B0502040204020203" pitchFamily="34" charset="0"/>
+              </a:rPr>
+              <a:t>detalla</a:t>
+            </a:r>
+            <a:r>
+              <a:rPr lang="en-US" sz="1200" dirty="0">
+                <a:solidFill>
+                  <a:srgbClr val="222222"/>
+                </a:solidFill>
+                <a:latin typeface="Segoe UI" panose="020B0502040204020203" pitchFamily="34" charset="0"/>
+              </a:rPr>
+              <a:t> de la </a:t>
+            </a:r>
+            <a:r>
+              <a:rPr lang="en-US" sz="1200" dirty="0" err="1">
+                <a:solidFill>
+                  <a:srgbClr val="222222"/>
+                </a:solidFill>
+                <a:latin typeface="Segoe UI" panose="020B0502040204020203" pitchFamily="34" charset="0"/>
+              </a:rPr>
+              <a:t>cantidad</a:t>
+            </a:r>
+            <a:r>
+              <a:rPr lang="en-US" sz="1200" dirty="0">
+                <a:solidFill>
+                  <a:srgbClr val="222222"/>
+                </a:solidFill>
+                <a:latin typeface="Segoe UI" panose="020B0502040204020203" pitchFamily="34" charset="0"/>
+              </a:rPr>
+              <a:t> de</a:t>
+            </a:r>
+            <a:r>
+              <a:rPr lang="en-US" sz="1200" b="1" dirty="0">
+                <a:solidFill>
+                  <a:srgbClr val="222222"/>
+                </a:solidFill>
+                <a:latin typeface="Segoe UI" panose="020B0502040204020203" pitchFamily="34" charset="0"/>
+              </a:rPr>
+              <a:t> Kits/</a:t>
+            </a:r>
+            <a:r>
+              <a:rPr lang="en-US" sz="1200" b="1" dirty="0" err="1">
+                <a:solidFill>
+                  <a:srgbClr val="222222"/>
+                </a:solidFill>
+                <a:latin typeface="Segoe UI" panose="020B0502040204020203" pitchFamily="34" charset="0"/>
+              </a:rPr>
+              <a:t>Patrones</a:t>
+            </a:r>
+            <a:r>
+              <a:rPr lang="en-US" sz="1200" b="1" dirty="0">
+                <a:solidFill>
+                  <a:srgbClr val="222222"/>
+                </a:solidFill>
+                <a:latin typeface="Segoe UI" panose="020B0502040204020203" pitchFamily="34" charset="0"/>
+              </a:rPr>
+              <a:t>/</a:t>
+            </a:r>
+            <a:r>
+              <a:rPr lang="en-US" sz="1200" b="1" dirty="0" err="1">
+                <a:solidFill>
+                  <a:srgbClr val="222222"/>
+                </a:solidFill>
+                <a:latin typeface="Segoe UI" panose="020B0502040204020203" pitchFamily="34" charset="0"/>
+              </a:rPr>
+              <a:t>Piezas</a:t>
+            </a:r>
+            <a:r>
+              <a:rPr lang="en-US" sz="1200" b="1" dirty="0">
+                <a:solidFill>
+                  <a:srgbClr val="222222"/>
+                </a:solidFill>
+                <a:latin typeface="Segoe UI" panose="020B0502040204020203" pitchFamily="34" charset="0"/>
+              </a:rPr>
+              <a:t> </a:t>
+            </a:r>
+            <a:r>
+              <a:rPr lang="en-US" sz="1200" dirty="0" err="1">
+                <a:solidFill>
+                  <a:srgbClr val="222222"/>
+                </a:solidFill>
+                <a:latin typeface="Segoe UI" panose="020B0502040204020203" pitchFamily="34" charset="0"/>
+              </a:rPr>
+              <a:t>escaneados</a:t>
+            </a:r>
+            <a:r>
+              <a:rPr lang="en-US" sz="1200" dirty="0">
+                <a:solidFill>
+                  <a:srgbClr val="222222"/>
+                </a:solidFill>
+                <a:latin typeface="Segoe UI" panose="020B0502040204020203" pitchFamily="34" charset="0"/>
+              </a:rPr>
+              <a:t> </a:t>
+            </a:r>
+            <a:r>
+              <a:rPr lang="en-US" sz="1200" dirty="0" err="1">
+                <a:solidFill>
+                  <a:srgbClr val="222222"/>
+                </a:solidFill>
+                <a:latin typeface="Segoe UI" panose="020B0502040204020203" pitchFamily="34" charset="0"/>
+              </a:rPr>
+              <a:t>en</a:t>
+            </a:r>
+            <a:r>
+              <a:rPr lang="en-US" sz="1200" dirty="0">
+                <a:solidFill>
+                  <a:srgbClr val="222222"/>
+                </a:solidFill>
+                <a:latin typeface="Segoe UI" panose="020B0502040204020203" pitchFamily="34" charset="0"/>
+              </a:rPr>
+              <a:t> </a:t>
+            </a:r>
+            <a:r>
+              <a:rPr lang="en-US" sz="1200" dirty="0" err="1">
+                <a:solidFill>
+                  <a:srgbClr val="222222"/>
+                </a:solidFill>
+                <a:latin typeface="Segoe UI" panose="020B0502040204020203" pitchFamily="34" charset="0"/>
+              </a:rPr>
+              <a:t>cada</a:t>
+            </a:r>
+            <a:r>
+              <a:rPr lang="en-US" sz="1200" dirty="0">
+                <a:solidFill>
+                  <a:srgbClr val="222222"/>
+                </a:solidFill>
+                <a:latin typeface="Segoe UI" panose="020B0502040204020203" pitchFamily="34" charset="0"/>
+              </a:rPr>
+              <a:t> uno de los </a:t>
+            </a:r>
+            <a:r>
+              <a:rPr lang="en-US" sz="1200" dirty="0" err="1">
+                <a:solidFill>
+                  <a:srgbClr val="222222"/>
+                </a:solidFill>
+                <a:latin typeface="Segoe UI" panose="020B0502040204020203" pitchFamily="34" charset="0"/>
+              </a:rPr>
+              <a:t>procesos</a:t>
+            </a:r>
+            <a:r>
+              <a:rPr lang="en-US" sz="1200" dirty="0">
+                <a:solidFill>
+                  <a:srgbClr val="222222"/>
+                </a:solidFill>
+                <a:latin typeface="Segoe UI" panose="020B0502040204020203" pitchFamily="34" charset="0"/>
+              </a:rPr>
+              <a:t>, las </a:t>
+            </a:r>
+            <a:r>
+              <a:rPr lang="en-US" sz="1200" dirty="0" err="1">
+                <a:solidFill>
+                  <a:srgbClr val="222222"/>
+                </a:solidFill>
+                <a:latin typeface="Segoe UI" panose="020B0502040204020203" pitchFamily="34" charset="0"/>
+              </a:rPr>
+              <a:t>busquedas</a:t>
+            </a:r>
+            <a:r>
+              <a:rPr lang="en-US" sz="1200" dirty="0">
+                <a:solidFill>
+                  <a:srgbClr val="222222"/>
+                </a:solidFill>
+                <a:latin typeface="Segoe UI" panose="020B0502040204020203" pitchFamily="34" charset="0"/>
+              </a:rPr>
+              <a:t> </a:t>
+            </a:r>
+            <a:r>
+              <a:rPr lang="en-US" sz="1200" dirty="0" err="1">
+                <a:solidFill>
+                  <a:srgbClr val="222222"/>
+                </a:solidFill>
+                <a:latin typeface="Segoe UI" panose="020B0502040204020203" pitchFamily="34" charset="0"/>
+              </a:rPr>
+              <a:t>pueden</a:t>
+            </a:r>
+            <a:r>
+              <a:rPr lang="en-US" sz="1200" dirty="0">
+                <a:solidFill>
+                  <a:srgbClr val="222222"/>
+                </a:solidFill>
+                <a:latin typeface="Segoe UI" panose="020B0502040204020203" pitchFamily="34" charset="0"/>
+              </a:rPr>
+              <a:t> </a:t>
+            </a:r>
+            <a:r>
+              <a:rPr lang="en-US" sz="1200" dirty="0" err="1">
+                <a:solidFill>
+                  <a:srgbClr val="222222"/>
+                </a:solidFill>
+                <a:latin typeface="Segoe UI" panose="020B0502040204020203" pitchFamily="34" charset="0"/>
+              </a:rPr>
+              <a:t>realizarse</a:t>
+            </a:r>
+            <a:r>
+              <a:rPr lang="en-US" sz="1200" dirty="0">
+                <a:solidFill>
+                  <a:srgbClr val="222222"/>
+                </a:solidFill>
+                <a:latin typeface="Segoe UI" panose="020B0502040204020203" pitchFamily="34" charset="0"/>
+              </a:rPr>
+              <a:t> por un</a:t>
+            </a:r>
+            <a:r>
+              <a:rPr lang="en-US" sz="1200" b="1" dirty="0">
+                <a:solidFill>
+                  <a:srgbClr val="222222"/>
+                </a:solidFill>
+                <a:latin typeface="Segoe UI" panose="020B0502040204020203" pitchFamily="34" charset="0"/>
+              </a:rPr>
+              <a:t> </a:t>
+            </a:r>
+            <a:r>
+              <a:rPr lang="en-US" sz="1200" b="1" dirty="0" err="1">
+                <a:solidFill>
+                  <a:srgbClr val="222222"/>
+                </a:solidFill>
+                <a:latin typeface="Segoe UI" panose="020B0502040204020203" pitchFamily="34" charset="0"/>
+              </a:rPr>
+              <a:t>rango</a:t>
+            </a:r>
+            <a:r>
+              <a:rPr lang="en-US" sz="1200" b="1" dirty="0">
+                <a:solidFill>
+                  <a:srgbClr val="222222"/>
+                </a:solidFill>
+                <a:latin typeface="Segoe UI" panose="020B0502040204020203" pitchFamily="34" charset="0"/>
+              </a:rPr>
+              <a:t> de </a:t>
+            </a:r>
+            <a:r>
+              <a:rPr lang="en-US" sz="1200" b="1" dirty="0" err="1">
+                <a:solidFill>
+                  <a:srgbClr val="222222"/>
+                </a:solidFill>
+                <a:latin typeface="Segoe UI" panose="020B0502040204020203" pitchFamily="34" charset="0"/>
+              </a:rPr>
+              <a:t>fechas</a:t>
+            </a:r>
+            <a:r>
+              <a:rPr lang="en-US" sz="1200" dirty="0">
+                <a:solidFill>
+                  <a:srgbClr val="222222"/>
+                </a:solidFill>
+                <a:latin typeface="Segoe UI" panose="020B0502040204020203" pitchFamily="34" charset="0"/>
+              </a:rPr>
+              <a:t>, </a:t>
+            </a:r>
+            <a:r>
+              <a:rPr lang="en-US" sz="1200" b="1" dirty="0" err="1">
+                <a:solidFill>
+                  <a:srgbClr val="222222"/>
+                </a:solidFill>
+                <a:latin typeface="Segoe UI" panose="020B0502040204020203" pitchFamily="34" charset="0"/>
+              </a:rPr>
+              <a:t>Cliente</a:t>
+            </a:r>
+            <a:r>
+              <a:rPr lang="en-US" sz="1200" dirty="0">
+                <a:solidFill>
+                  <a:srgbClr val="222222"/>
+                </a:solidFill>
+                <a:latin typeface="Segoe UI" panose="020B0502040204020203" pitchFamily="34" charset="0"/>
+              </a:rPr>
+              <a:t>, </a:t>
+            </a:r>
+            <a:r>
+              <a:rPr lang="en-US" sz="1200" b="1" dirty="0" err="1">
+                <a:solidFill>
+                  <a:srgbClr val="222222"/>
+                </a:solidFill>
+                <a:latin typeface="Segoe UI" panose="020B0502040204020203" pitchFamily="34" charset="0"/>
+              </a:rPr>
+              <a:t>Proceso</a:t>
+            </a:r>
+            <a:r>
+              <a:rPr lang="en-US" sz="1200" dirty="0">
+                <a:solidFill>
+                  <a:srgbClr val="222222"/>
+                </a:solidFill>
+                <a:latin typeface="Segoe UI" panose="020B0502040204020203" pitchFamily="34" charset="0"/>
+              </a:rPr>
+              <a:t> y </a:t>
+            </a:r>
+            <a:r>
+              <a:rPr lang="en-US" sz="1200" b="1" dirty="0" err="1">
+                <a:solidFill>
+                  <a:srgbClr val="222222"/>
+                </a:solidFill>
+                <a:latin typeface="Segoe UI" panose="020B0502040204020203" pitchFamily="34" charset="0"/>
+              </a:rPr>
+              <a:t>Turno</a:t>
+            </a:r>
+            <a:r>
+              <a:rPr lang="en-US" sz="1200" b="1" dirty="0">
+                <a:solidFill>
+                  <a:srgbClr val="222222"/>
+                </a:solidFill>
+                <a:latin typeface="Segoe UI" panose="020B0502040204020203" pitchFamily="34" charset="0"/>
+              </a:rPr>
+              <a:t>, </a:t>
+            </a:r>
+            <a:r>
+              <a:rPr lang="en-US" sz="1200" dirty="0" err="1">
+                <a:solidFill>
+                  <a:srgbClr val="222222"/>
+                </a:solidFill>
+                <a:latin typeface="Segoe UI" panose="020B0502040204020203" pitchFamily="34" charset="0"/>
+              </a:rPr>
+              <a:t>si</a:t>
+            </a:r>
+            <a:r>
+              <a:rPr lang="en-US" sz="1200" dirty="0">
+                <a:solidFill>
+                  <a:srgbClr val="222222"/>
+                </a:solidFill>
+                <a:latin typeface="Segoe UI" panose="020B0502040204020203" pitchFamily="34" charset="0"/>
+              </a:rPr>
+              <a:t> se </a:t>
+            </a:r>
+            <a:r>
+              <a:rPr lang="en-US" sz="1200" dirty="0" err="1">
+                <a:solidFill>
+                  <a:srgbClr val="222222"/>
+                </a:solidFill>
+                <a:latin typeface="Segoe UI" panose="020B0502040204020203" pitchFamily="34" charset="0"/>
+              </a:rPr>
+              <a:t>requiere</a:t>
+            </a:r>
+            <a:r>
+              <a:rPr lang="en-US" sz="1200" dirty="0">
+                <a:solidFill>
+                  <a:srgbClr val="222222"/>
+                </a:solidFill>
+                <a:latin typeface="Segoe UI" panose="020B0502040204020203" pitchFamily="34" charset="0"/>
+              </a:rPr>
+              <a:t> se </a:t>
+            </a:r>
+            <a:r>
+              <a:rPr lang="en-US" sz="1200" dirty="0" err="1">
+                <a:solidFill>
+                  <a:srgbClr val="222222"/>
+                </a:solidFill>
+                <a:latin typeface="Segoe UI" panose="020B0502040204020203" pitchFamily="34" charset="0"/>
+              </a:rPr>
+              <a:t>puede</a:t>
+            </a:r>
+            <a:r>
+              <a:rPr lang="en-US" sz="1200" dirty="0">
+                <a:solidFill>
+                  <a:srgbClr val="222222"/>
+                </a:solidFill>
+                <a:latin typeface="Segoe UI" panose="020B0502040204020203" pitchFamily="34" charset="0"/>
+              </a:rPr>
+              <a:t> </a:t>
+            </a:r>
+            <a:r>
+              <a:rPr lang="en-US" sz="1200" dirty="0" err="1">
+                <a:solidFill>
+                  <a:srgbClr val="222222"/>
+                </a:solidFill>
+                <a:latin typeface="Segoe UI" panose="020B0502040204020203" pitchFamily="34" charset="0"/>
+              </a:rPr>
+              <a:t>descargar</a:t>
+            </a:r>
+            <a:r>
+              <a:rPr lang="en-US" sz="1200" dirty="0">
+                <a:solidFill>
+                  <a:srgbClr val="222222"/>
+                </a:solidFill>
+                <a:latin typeface="Segoe UI" panose="020B0502040204020203" pitchFamily="34" charset="0"/>
+              </a:rPr>
+              <a:t> la </a:t>
+            </a:r>
+            <a:r>
+              <a:rPr lang="en-US" sz="1200" dirty="0" err="1">
+                <a:solidFill>
+                  <a:srgbClr val="222222"/>
+                </a:solidFill>
+                <a:latin typeface="Segoe UI" panose="020B0502040204020203" pitchFamily="34" charset="0"/>
+              </a:rPr>
+              <a:t>información</a:t>
+            </a:r>
+            <a:r>
+              <a:rPr lang="en-US" sz="1200" dirty="0">
+                <a:solidFill>
+                  <a:srgbClr val="222222"/>
+                </a:solidFill>
+                <a:latin typeface="Segoe UI" panose="020B0502040204020203" pitchFamily="34" charset="0"/>
+              </a:rPr>
+              <a:t> a un </a:t>
+            </a:r>
+            <a:r>
+              <a:rPr lang="en-US" sz="1200" dirty="0" err="1">
+                <a:solidFill>
+                  <a:srgbClr val="222222"/>
+                </a:solidFill>
+                <a:latin typeface="Segoe UI" panose="020B0502040204020203" pitchFamily="34" charset="0"/>
+              </a:rPr>
+              <a:t>archivo</a:t>
+            </a:r>
+            <a:r>
+              <a:rPr lang="en-US" sz="1200" dirty="0">
+                <a:solidFill>
+                  <a:srgbClr val="222222"/>
+                </a:solidFill>
+                <a:latin typeface="Segoe UI" panose="020B0502040204020203" pitchFamily="34" charset="0"/>
+              </a:rPr>
+              <a:t> </a:t>
+            </a:r>
+            <a:r>
+              <a:rPr lang="en-US" sz="1200" b="1" dirty="0">
+                <a:solidFill>
+                  <a:srgbClr val="222222"/>
+                </a:solidFill>
+                <a:latin typeface="Segoe UI" panose="020B0502040204020203" pitchFamily="34" charset="0"/>
+              </a:rPr>
+              <a:t>Excel</a:t>
+            </a:r>
+            <a:r>
+              <a:rPr lang="es-ES" sz="1200" b="1" dirty="0">
+                <a:solidFill>
+                  <a:srgbClr val="222222"/>
+                </a:solidFill>
+                <a:latin typeface="Segoe UI" panose="020B0502040204020203" pitchFamily="34" charset="0"/>
+              </a:rPr>
+              <a:t>.</a:t>
+            </a:r>
+            <a:endParaRPr lang="es-ES" sz="1200" b="0" i="0" dirty="0">
+              <a:solidFill>
+                <a:srgbClr val="222222"/>
+              </a:solidFill>
+              <a:effectLst/>
+              <a:latin typeface="Segoe UI" panose="020B0502040204020203" pitchFamily="34" charset="0"/>
+            </a:endParaRPr>
+          </a:p>
+        </p:txBody>
+      </p:sp>
+      <p:pic>
+        <p:nvPicPr>
+          <p:cNvPr id="11" name="Imagen 10" descr="Interfaz de usuario gráfica, Aplicación, Tabla, Excel&#10;&#10;Descripción generada automáticamente">
+            <a:extLst>
+              <a:ext uri="{FF2B5EF4-FFF2-40B4-BE49-F238E27FC236}">
+                <a16:creationId xmlns:a16="http://schemas.microsoft.com/office/drawing/2014/main" id="{24AAC71E-DE7E-4A99-A211-CAE26A5A713C}"/>
+              </a:ext>
+            </a:extLst>
+          </p:cNvPr>
+          <p:cNvPicPr>
+            <a:picLocks noChangeAspect="1"/>
+          </p:cNvPicPr>
+          <p:nvPr/>
+        </p:nvPicPr>
+        <p:blipFill>
+          <a:blip r:embed="rId2">
+            <a:extLst>
+              <a:ext uri="{28A0092B-C50C-407E-A947-70E740481C1C}">
+                <a14:useLocalDpi xmlns:a14="http://schemas.microsoft.com/office/drawing/2010/main" val="0"/>
+              </a:ext>
+            </a:extLst>
+          </a:blip>
+          <a:stretch>
+            <a:fillRect/>
+          </a:stretch>
+        </p:blipFill>
+        <p:spPr>
+          <a:xfrm>
+            <a:off x="1115616" y="1845028"/>
+            <a:ext cx="7956376" cy="4968348"/>
+          </a:xfrm>
+          <a:prstGeom prst="rect">
+            <a:avLst/>
+          </a:prstGeom>
+        </p:spPr>
+      </p:pic>
+      <p:sp>
+        <p:nvSpPr>
+          <p:cNvPr id="12" name="Rectángulo 11">
+            <a:extLst>
+              <a:ext uri="{FF2B5EF4-FFF2-40B4-BE49-F238E27FC236}">
+                <a16:creationId xmlns:a16="http://schemas.microsoft.com/office/drawing/2014/main" id="{0FB7EE74-224C-43BD-B116-6217EFFC0123}"/>
+              </a:ext>
+            </a:extLst>
+          </p:cNvPr>
+          <p:cNvSpPr/>
+          <p:nvPr/>
+        </p:nvSpPr>
+        <p:spPr>
+          <a:xfrm>
+            <a:off x="1763688" y="2492895"/>
+            <a:ext cx="2520280" cy="329893"/>
+          </a:xfrm>
+          <a:prstGeom prst="rect">
+            <a:avLst/>
+          </a:prstGeom>
+          <a:noFill/>
+          <a:ln>
+            <a:solidFill>
+              <a:srgbClr val="FF0000"/>
+            </a:solidFill>
+          </a:ln>
+        </p:spPr>
+        <p:style>
+          <a:lnRef idx="2">
+            <a:schemeClr val="accent1">
+              <a:shade val="50000"/>
+            </a:schemeClr>
+          </a:lnRef>
+          <a:fillRef idx="1">
+            <a:schemeClr val="accent1"/>
+          </a:fillRef>
+          <a:effectRef idx="0">
+            <a:schemeClr val="accent1"/>
+          </a:effectRef>
+          <a:fontRef idx="minor">
+            <a:schemeClr val="lt1"/>
+          </a:fontRef>
+        </p:style>
+        <p:txBody>
+          <a:bodyPr rtlCol="0" anchor="ctr"/>
+          <a:lstStyle/>
+          <a:p>
+            <a:pPr algn="ctr"/>
+            <a:endParaRPr lang="en-US"/>
+          </a:p>
+        </p:txBody>
+      </p:sp>
+    </p:spTree>
+    <p:extLst>
+      <p:ext uri="{BB962C8B-B14F-4D97-AF65-F5344CB8AC3E}">
+        <p14:creationId xmlns:p14="http://schemas.microsoft.com/office/powerpoint/2010/main" val="941744193"/>
+      </p:ext>
+    </p:extLst>
+  </p:cSld>
+  <p:clrMapOvr>
+    <a:masterClrMapping/>
+  </p:clrMapOvr>
+</p:sld>
+</file>
+
+<file path=ppt/slides/slide3.xml><?xml version="1.0" encoding="utf-8"?>
+<p:sld xmlns:a="http://schemas.openxmlformats.org/drawingml/2006/main" xmlns:r="http://schemas.openxmlformats.org/officeDocument/2006/relationships" xmlns:p="http://schemas.openxmlformats.org/presentationml/2006/main">
+  <p:cSld>
+    <p:spTree>
+      <p:nvGrpSpPr>
+        <p:cNvPr id="1" name=""/>
+        <p:cNvGrpSpPr/>
+        <p:nvPr/>
+      </p:nvGrpSpPr>
+      <p:grpSpPr>
+        <a:xfrm>
+          <a:off x="0" y="0"/>
+          <a:ext cx="0" cy="0"/>
+          <a:chOff x="0" y="0"/>
+          <a:chExt cx="0" cy="0"/>
+        </a:xfrm>
+      </p:grpSpPr>
+      <p:sp>
+        <p:nvSpPr>
+          <p:cNvPr id="5" name="Title 1"/>
+          <p:cNvSpPr txBox="1">
+            <a:spLocks/>
+          </p:cNvSpPr>
+          <p:nvPr/>
+        </p:nvSpPr>
+        <p:spPr>
+          <a:xfrm>
+            <a:off x="1187624" y="2564904"/>
+            <a:ext cx="7772400" cy="1470025"/>
+          </a:xfrm>
+          <a:prstGeom prst="rect">
+            <a:avLst/>
+          </a:prstGeom>
+        </p:spPr>
+        <p:txBody>
+          <a:bodyPr vert="horz" lIns="91440" tIns="45720" rIns="91440" bIns="45720" rtlCol="0" anchor="ctr">
+            <a:normAutofit/>
+          </a:bodyPr>
+          <a:lstStyle>
+            <a:lvl1pPr algn="ctr" defTabSz="914400" rtl="0" eaLnBrk="1" latinLnBrk="0" hangingPunct="1">
+              <a:spcBef>
+                <a:spcPct val="0"/>
+              </a:spcBef>
+              <a:buNone/>
+              <a:defRPr sz="4400" kern="1200">
+                <a:solidFill>
+                  <a:schemeClr val="tx1"/>
+                </a:solidFill>
+                <a:latin typeface="+mj-lt"/>
+                <a:ea typeface="+mj-ea"/>
+                <a:cs typeface="+mj-cs"/>
+              </a:defRPr>
+            </a:lvl1pPr>
+          </a:lstStyle>
+          <a:p>
+            <a:r>
+              <a:rPr lang="es-MX" b="1" dirty="0">
+                <a:latin typeface="Century Gothic" panose="020B0502020202020204" pitchFamily="34" charset="0"/>
+              </a:rPr>
+              <a:t>07/06/2021 – 11/06/2021</a:t>
+            </a:r>
+            <a:endParaRPr lang="es-MX" dirty="0">
+              <a:latin typeface="Century Gothic" panose="020B0502020202020204" pitchFamily="34" charset="0"/>
+            </a:endParaRPr>
+          </a:p>
+        </p:txBody>
+      </p:sp>
+    </p:spTree>
+    <p:extLst>
+      <p:ext uri="{BB962C8B-B14F-4D97-AF65-F5344CB8AC3E}">
+        <p14:creationId xmlns:p14="http://schemas.microsoft.com/office/powerpoint/2010/main" val="559317128"/>
+      </p:ext>
+    </p:extLst>
+  </p:cSld>
+  <p:clrMapOvr>
+    <a:masterClrMapping/>
+  </p:clrMapOvr>
+</p:sld>
+</file>
+
+<file path=ppt/slides/slide4.xml><?xml version="1.0" encoding="utf-8"?>
 <p:sld xmlns:a="http://schemas.openxmlformats.org/drawingml/2006/main" xmlns:r="http://schemas.openxmlformats.org/officeDocument/2006/relationships" xmlns:p="http://schemas.openxmlformats.org/presentationml/2006/main">
   <p:cSld>
     <p:spTree>
@@ -4005,7 +5024,7 @@
 </p:sld>
 </file>
 
-<file path=ppt/slides/slide3.xml><?xml version="1.0" encoding="utf-8"?>
+<file path=ppt/slides/slide5.xml><?xml version="1.0" encoding="utf-8"?>
 <p:sld xmlns:a="http://schemas.openxmlformats.org/drawingml/2006/main" xmlns:r="http://schemas.openxmlformats.org/officeDocument/2006/relationships" xmlns:p="http://schemas.openxmlformats.org/presentationml/2006/main">
   <p:cSld>
     <p:spTree>
@@ -4371,7 +5390,7 @@
 </p:sld>
 </file>
 
-<file path=ppt/slides/slide4.xml><?xml version="1.0" encoding="utf-8"?>
+<file path=ppt/slides/slide6.xml><?xml version="1.0" encoding="utf-8"?>
 <p:sld xmlns:a="http://schemas.openxmlformats.org/drawingml/2006/main" xmlns:r="http://schemas.openxmlformats.org/officeDocument/2006/relationships" xmlns:p="http://schemas.openxmlformats.org/presentationml/2006/main">
   <p:cSld>
     <p:spTree>
@@ -4451,7 +5470,7 @@
 </p:sld>
 </file>
 
-<file path=ppt/slides/slide5.xml><?xml version="1.0" encoding="utf-8"?>
+<file path=ppt/slides/slide7.xml><?xml version="1.0" encoding="utf-8"?>
 <p:sld xmlns:a="http://schemas.openxmlformats.org/drawingml/2006/main" xmlns:r="http://schemas.openxmlformats.org/officeDocument/2006/relationships" xmlns:p="http://schemas.openxmlformats.org/presentationml/2006/main">
   <p:cSld>
     <p:spTree>
@@ -4849,7 +5868,7 @@
 </p:sld>
 </file>
 
-<file path=ppt/slides/slide6.xml><?xml version="1.0" encoding="utf-8"?>
+<file path=ppt/slides/slide8.xml><?xml version="1.0" encoding="utf-8"?>
 <p:sld xmlns:a="http://schemas.openxmlformats.org/drawingml/2006/main" xmlns:r="http://schemas.openxmlformats.org/officeDocument/2006/relationships" xmlns:p="http://schemas.openxmlformats.org/presentationml/2006/main">
   <p:cSld>
     <p:spTree>

</xml_diff>